<commit_message>
deck: final SIH submission QA pass (visual fixes only)
No text, claims, slide structure or USP wording changed (text verified
identical on all 6 slides).
- Slide 2: Innovation band heading, USP titles and proof numbers enlarged;
  clearer gauge icon for USP 03; more space above the metric strips;
  pipeline captions 8 -> 8.5 pt
- Slide 3: highlighted U-Net step widened so its caption no longer touches
  the card edge; step captions 8 -> 8.5 pt
- Slide 4: IMPLEMENTED / PLANNED tags raised to the 8 pt minimum
- Slide 5: storm icon for cyclone forecasters (tornado glyph read as lines)
- Builder: only the team-name oval counts as template furniture, so
  rebuilding from an already-built deck no longer duplicates round badges

Co-Authored-By: Claude Opus 5.5 <noreply@anthropic.com>
Claude-Session: https://claude.ai/code/session_011ZpLQrPqPcimbyYNKERyYb
</commit_message>
<xml_diff>
--- a/deliverables/OceanSight_SIH2026_Idea_Submission.pptx
+++ b/deliverables/OceanSight_SIH2026_Idea_Submission.pptx
@@ -6965,7 +6965,7 @@
               </a:lnSpc>
             </a:pPr>
             <a:r>
-              <a:rPr sz="800" b="0" i="0">
+              <a:rPr sz="850" b="0" i="0">
                 <a:solidFill>
                   <a:srgbClr val="1B2330"/>
                 </a:solidFill>
@@ -6983,7 +6983,7 @@
               </a:lnSpc>
             </a:pPr>
             <a:r>
-              <a:rPr sz="800" b="0" i="0">
+              <a:rPr sz="850" b="0" i="0">
                 <a:solidFill>
                   <a:srgbClr val="1B2330"/>
                 </a:solidFill>
@@ -7151,7 +7151,7 @@
               </a:lnSpc>
             </a:pPr>
             <a:r>
-              <a:rPr sz="800" b="0" i="0">
+              <a:rPr sz="850" b="0" i="0">
                 <a:solidFill>
                   <a:srgbClr val="1B2330"/>
                 </a:solidFill>
@@ -7169,7 +7169,7 @@
               </a:lnSpc>
             </a:pPr>
             <a:r>
-              <a:rPr sz="800" b="0" i="0">
+              <a:rPr sz="850" b="0" i="0">
                 <a:solidFill>
                   <a:srgbClr val="1B2330"/>
                 </a:solidFill>
@@ -7337,7 +7337,7 @@
               </a:lnSpc>
             </a:pPr>
             <a:r>
-              <a:rPr sz="800" b="0" i="0">
+              <a:rPr sz="850" b="0" i="0">
                 <a:solidFill>
                   <a:srgbClr val="FFFFFF"/>
                 </a:solidFill>
@@ -7355,7 +7355,7 @@
               </a:lnSpc>
             </a:pPr>
             <a:r>
-              <a:rPr sz="800" b="0" i="0">
+              <a:rPr sz="850" b="0" i="0">
                 <a:solidFill>
                   <a:srgbClr val="FFFFFF"/>
                 </a:solidFill>
@@ -7523,7 +7523,7 @@
               </a:lnSpc>
             </a:pPr>
             <a:r>
-              <a:rPr sz="800" b="0" i="0">
+              <a:rPr sz="850" b="0" i="0">
                 <a:solidFill>
                   <a:srgbClr val="1B2330"/>
                 </a:solidFill>
@@ -7541,7 +7541,7 @@
               </a:lnSpc>
             </a:pPr>
             <a:r>
-              <a:rPr sz="800" b="0" i="0">
+              <a:rPr sz="850" b="0" i="0">
                 <a:solidFill>
                   <a:srgbClr val="1B2330"/>
                 </a:solidFill>
@@ -7709,7 +7709,7 @@
               </a:lnSpc>
             </a:pPr>
             <a:r>
-              <a:rPr sz="800" b="0" i="0">
+              <a:rPr sz="850" b="0" i="0">
                 <a:solidFill>
                   <a:srgbClr val="1B2330"/>
                 </a:solidFill>
@@ -7727,7 +7727,7 @@
               </a:lnSpc>
             </a:pPr>
             <a:r>
-              <a:rPr sz="800" b="0" i="0">
+              <a:rPr sz="850" b="0" i="0">
                 <a:solidFill>
                   <a:srgbClr val="1B2330"/>
                 </a:solidFill>
@@ -7895,7 +7895,7 @@
               </a:lnSpc>
             </a:pPr>
             <a:r>
-              <a:rPr sz="800" b="0" i="0">
+              <a:rPr sz="850" b="0" i="0">
                 <a:solidFill>
                   <a:srgbClr val="1B2330"/>
                 </a:solidFill>
@@ -7913,7 +7913,7 @@
               </a:lnSpc>
             </a:pPr>
             <a:r>
-              <a:rPr sz="800" b="0" i="0">
+              <a:rPr sz="850" b="0" i="0">
                 <a:solidFill>
                   <a:srgbClr val="1B2330"/>
                 </a:solidFill>
@@ -8151,7 +8151,7 @@
               </a:lnSpc>
             </a:pPr>
             <a:r>
-              <a:rPr sz="1400" b="1" i="0">
+              <a:rPr sz="1500" b="1" i="0">
                 <a:solidFill>
                   <a:srgbClr val="FFFFFF"/>
                 </a:solidFill>
@@ -8184,11 +8184,11 @@
         <p:spPr>
           <a:xfrm>
             <a:off x="457200" y="4608575"/>
-            <a:ext cx="3648456" cy="1335024"/>
+            <a:ext cx="3648456" cy="1371600"/>
           </a:xfrm>
           <a:prstGeom prst="roundRect">
             <a:avLst>
-              <a:gd name="adj" fmla="val 6849"/>
+              <a:gd name="adj" fmla="val 6666"/>
             </a:avLst>
           </a:prstGeom>
           <a:solidFill>
@@ -8306,8 +8306,8 @@
         </p:nvSpPr>
         <p:spPr>
           <a:xfrm>
-            <a:off x="1078992" y="4855463"/>
-            <a:ext cx="2916936" cy="256032"/>
+            <a:off x="1078992" y="4846319"/>
+            <a:ext cx="2916936" cy="274320"/>
           </a:xfrm>
           <a:prstGeom prst="rect">
             <a:avLst/>
@@ -8326,7 +8326,7 @@
               </a:lnSpc>
             </a:pPr>
             <a:r>
-              <a:rPr sz="1250" b="1" i="0">
+              <a:rPr sz="1350" b="1" i="0">
                 <a:solidFill>
                   <a:srgbClr val="0B2F4E"/>
                 </a:solidFill>
@@ -8347,7 +8347,7 @@
         </p:nvSpPr>
         <p:spPr>
           <a:xfrm>
-            <a:off x="585216" y="5138927"/>
+            <a:off x="585216" y="5120640"/>
             <a:ext cx="3392424" cy="420624"/>
           </a:xfrm>
           <a:prstGeom prst="rect">
@@ -8389,11 +8389,11 @@
         <p:spPr>
           <a:xfrm>
             <a:off x="548640" y="5596127"/>
-            <a:ext cx="3465576" cy="274320"/>
+            <a:ext cx="3465576" cy="310896"/>
           </a:xfrm>
           <a:prstGeom prst="roundRect">
             <a:avLst>
-              <a:gd name="adj" fmla="val 23333"/>
+              <a:gd name="adj" fmla="val 23529"/>
             </a:avLst>
           </a:prstGeom>
           <a:solidFill>
@@ -8418,8 +8418,8 @@
         </p:nvSpPr>
         <p:spPr>
           <a:xfrm>
-            <a:off x="640080" y="5596127"/>
-            <a:ext cx="3282696" cy="274320"/>
+            <a:off x="603504" y="5596127"/>
+            <a:ext cx="3355848" cy="310896"/>
           </a:xfrm>
           <a:prstGeom prst="rect">
             <a:avLst/>
@@ -8438,7 +8438,7 @@
               </a:lnSpc>
             </a:pPr>
             <a:r>
-              <a:rPr sz="1500" b="1" i="0">
+              <a:rPr sz="1800" b="1" i="0">
                 <a:solidFill>
                   <a:srgbClr val="0E869A"/>
                 </a:solidFill>
@@ -8471,11 +8471,11 @@
         <p:spPr>
           <a:xfrm>
             <a:off x="4270248" y="4608575"/>
-            <a:ext cx="3648456" cy="1335024"/>
+            <a:ext cx="3648456" cy="1371600"/>
           </a:xfrm>
           <a:prstGeom prst="roundRect">
             <a:avLst>
-              <a:gd name="adj" fmla="val 6849"/>
+              <a:gd name="adj" fmla="val 6666"/>
             </a:avLst>
           </a:prstGeom>
           <a:solidFill>
@@ -8593,8 +8593,8 @@
         </p:nvSpPr>
         <p:spPr>
           <a:xfrm>
-            <a:off x="4892040" y="4855463"/>
-            <a:ext cx="2916936" cy="256032"/>
+            <a:off x="4892040" y="4846319"/>
+            <a:ext cx="2916936" cy="274320"/>
           </a:xfrm>
           <a:prstGeom prst="rect">
             <a:avLst/>
@@ -8613,7 +8613,7 @@
               </a:lnSpc>
             </a:pPr>
             <a:r>
-              <a:rPr sz="1250" b="1" i="0">
+              <a:rPr sz="1350" b="1" i="0">
                 <a:solidFill>
                   <a:srgbClr val="0B2F4E"/>
                 </a:solidFill>
@@ -8634,7 +8634,7 @@
         </p:nvSpPr>
         <p:spPr>
           <a:xfrm>
-            <a:off x="4398264" y="5138927"/>
+            <a:off x="4398264" y="5120640"/>
             <a:ext cx="3392424" cy="420624"/>
           </a:xfrm>
           <a:prstGeom prst="rect">
@@ -8676,11 +8676,11 @@
         <p:spPr>
           <a:xfrm>
             <a:off x="4361688" y="5596127"/>
-            <a:ext cx="3465576" cy="274320"/>
+            <a:ext cx="3465576" cy="310896"/>
           </a:xfrm>
           <a:prstGeom prst="roundRect">
             <a:avLst>
-              <a:gd name="adj" fmla="val 23333"/>
+              <a:gd name="adj" fmla="val 23529"/>
             </a:avLst>
           </a:prstGeom>
           <a:solidFill>
@@ -8705,8 +8705,8 @@
         </p:nvSpPr>
         <p:spPr>
           <a:xfrm>
-            <a:off x="4453128" y="5596127"/>
-            <a:ext cx="3282696" cy="274320"/>
+            <a:off x="4416552" y="5596127"/>
+            <a:ext cx="3355848" cy="310896"/>
           </a:xfrm>
           <a:prstGeom prst="rect">
             <a:avLst/>
@@ -8725,7 +8725,7 @@
               </a:lnSpc>
             </a:pPr>
             <a:r>
-              <a:rPr sz="1500" b="1" i="0">
+              <a:rPr sz="1800" b="1" i="0">
                 <a:solidFill>
                   <a:srgbClr val="0E869A"/>
                 </a:solidFill>
@@ -8758,11 +8758,11 @@
         <p:spPr>
           <a:xfrm>
             <a:off x="8083296" y="4608575"/>
-            <a:ext cx="3648456" cy="1335024"/>
+            <a:ext cx="3648456" cy="1371600"/>
           </a:xfrm>
           <a:prstGeom prst="roundRect">
             <a:avLst>
-              <a:gd name="adj" fmla="val 6849"/>
+              <a:gd name="adj" fmla="val 6666"/>
             </a:avLst>
           </a:prstGeom>
           <a:solidFill>
@@ -8809,14 +8809,14 @@
       </p:sp>
       <p:pic>
         <p:nvPicPr>
-          <p:cNvPr id="15432" name="Picture 15431" descr="tornado-0E869A.png"/>
+          <p:cNvPr id="15432" name="Picture 15431" descr="gauge-0E869A.png"/>
           <p:cNvPicPr>
             <a:picLocks noChangeAspect="1"/>
           </p:cNvPicPr>
           <p:nvPr/>
         </p:nvPicPr>
         <p:blipFill>
-          <a:blip r:embed="rId18"/>
+          <a:blip r:embed="rId12"/>
           <a:stretch>
             <a:fillRect/>
           </a:stretch>
@@ -8880,8 +8880,8 @@
         </p:nvSpPr>
         <p:spPr>
           <a:xfrm>
-            <a:off x="8705088" y="4855463"/>
-            <a:ext cx="2916936" cy="256032"/>
+            <a:off x="8705088" y="4846319"/>
+            <a:ext cx="2916936" cy="274320"/>
           </a:xfrm>
           <a:prstGeom prst="rect">
             <a:avLst/>
@@ -8900,7 +8900,7 @@
               </a:lnSpc>
             </a:pPr>
             <a:r>
-              <a:rPr sz="1250" b="1" i="0">
+              <a:rPr sz="1350" b="1" i="0">
                 <a:solidFill>
                   <a:srgbClr val="0B2F4E"/>
                 </a:solidFill>
@@ -8921,7 +8921,7 @@
         </p:nvSpPr>
         <p:spPr>
           <a:xfrm>
-            <a:off x="8211312" y="5138927"/>
+            <a:off x="8211312" y="5120640"/>
             <a:ext cx="3392424" cy="420624"/>
           </a:xfrm>
           <a:prstGeom prst="rect">
@@ -8963,11 +8963,11 @@
         <p:spPr>
           <a:xfrm>
             <a:off x="8174736" y="5596127"/>
-            <a:ext cx="3465576" cy="274320"/>
+            <a:ext cx="3465576" cy="310896"/>
           </a:xfrm>
           <a:prstGeom prst="roundRect">
             <a:avLst>
-              <a:gd name="adj" fmla="val 23333"/>
+              <a:gd name="adj" fmla="val 23529"/>
             </a:avLst>
           </a:prstGeom>
           <a:solidFill>
@@ -8992,8 +8992,8 @@
         </p:nvSpPr>
         <p:spPr>
           <a:xfrm>
-            <a:off x="8266175" y="5596127"/>
-            <a:ext cx="3282696" cy="274320"/>
+            <a:off x="8229600" y="5596127"/>
+            <a:ext cx="3355848" cy="310896"/>
           </a:xfrm>
           <a:prstGeom prst="rect">
             <a:avLst/>
@@ -9012,7 +9012,7 @@
               </a:lnSpc>
             </a:pPr>
             <a:r>
-              <a:rPr sz="1500" b="1" i="0">
+              <a:rPr sz="1800" b="1" i="0">
                 <a:solidFill>
                   <a:srgbClr val="0E869A"/>
                 </a:solidFill>
@@ -9044,7 +9044,7 @@
         </p:nvSpPr>
         <p:spPr>
           <a:xfrm>
-            <a:off x="457200" y="5980175"/>
+            <a:off x="457200" y="5998463"/>
             <a:ext cx="11274552" cy="256032"/>
           </a:xfrm>
           <a:prstGeom prst="rect">
@@ -10895,7 +10895,7 @@
         <p:spPr>
           <a:xfrm>
             <a:off x="4526280" y="1554480"/>
-            <a:ext cx="1120140" cy="969264"/>
+            <a:ext cx="1078992" cy="969264"/>
           </a:xfrm>
           <a:prstGeom prst="roundRect">
             <a:avLst>
@@ -10926,7 +10926,7 @@
         </p:nvSpPr>
         <p:spPr>
           <a:xfrm>
-            <a:off x="4958334" y="1627632"/>
+            <a:off x="4937760" y="1627632"/>
             <a:ext cx="256032" cy="256032"/>
           </a:xfrm>
           <a:prstGeom prst="ellipse">
@@ -10954,7 +10954,7 @@
         </p:nvSpPr>
         <p:spPr>
           <a:xfrm>
-            <a:off x="4958334" y="1627632"/>
+            <a:off x="4937760" y="1627632"/>
             <a:ext cx="256032" cy="256032"/>
           </a:xfrm>
           <a:prstGeom prst="rect">
@@ -10996,7 +10996,7 @@
         <p:spPr>
           <a:xfrm>
             <a:off x="4526280" y="1920240"/>
-            <a:ext cx="1120140" cy="182880"/>
+            <a:ext cx="1078992" cy="182880"/>
           </a:xfrm>
           <a:prstGeom prst="rect">
             <a:avLst/>
@@ -11037,7 +11037,7 @@
         <p:spPr>
           <a:xfrm>
             <a:off x="4526280" y="2103120"/>
-            <a:ext cx="1120140" cy="384048"/>
+            <a:ext cx="1078992" cy="384048"/>
           </a:xfrm>
           <a:prstGeom prst="rect">
             <a:avLst/>
@@ -11045,7 +11045,7 @@
           <a:noFill/>
         </p:spPr>
         <p:txBody>
-          <a:bodyPr wrap="square" anchor="ctr" lIns="0" rIns="0" tIns="0" bIns="0">
+          <a:bodyPr wrap="square" anchor="ctr" lIns="27432" rIns="27432" tIns="27432" bIns="27432">
             <a:spAutoFit/>
           </a:bodyPr>
           <a:lstStyle/>
@@ -11056,7 +11056,7 @@
               </a:lnSpc>
             </a:pPr>
             <a:r>
-              <a:rPr sz="800" b="0" i="0">
+              <a:rPr sz="850" b="0" i="0">
                 <a:solidFill>
                   <a:srgbClr val="1B2330"/>
                 </a:solidFill>
@@ -11074,7 +11074,7 @@
               </a:lnSpc>
             </a:pPr>
             <a:r>
-              <a:rPr sz="800" b="0" i="0">
+              <a:rPr sz="850" b="0" i="0">
                 <a:solidFill>
                   <a:srgbClr val="1B2330"/>
                 </a:solidFill>
@@ -11095,7 +11095,7 @@
         </p:nvSpPr>
         <p:spPr>
           <a:xfrm>
-            <a:off x="5673852" y="1956816"/>
+            <a:off x="5632704" y="1956816"/>
             <a:ext cx="73152" cy="164592"/>
           </a:xfrm>
           <a:prstGeom prst="chevron">
@@ -11125,8 +11125,8 @@
         </p:nvSpPr>
         <p:spPr>
           <a:xfrm>
-            <a:off x="5774436" y="1554480"/>
-            <a:ext cx="1120140" cy="969264"/>
+            <a:off x="5733288" y="1554480"/>
+            <a:ext cx="1078992" cy="969264"/>
           </a:xfrm>
           <a:prstGeom prst="roundRect">
             <a:avLst>
@@ -11157,7 +11157,7 @@
         </p:nvSpPr>
         <p:spPr>
           <a:xfrm>
-            <a:off x="6206490" y="1627632"/>
+            <a:off x="6144768" y="1627632"/>
             <a:ext cx="256032" cy="256032"/>
           </a:xfrm>
           <a:prstGeom prst="ellipse">
@@ -11185,7 +11185,7 @@
         </p:nvSpPr>
         <p:spPr>
           <a:xfrm>
-            <a:off x="6206490" y="1627632"/>
+            <a:off x="6144768" y="1627632"/>
             <a:ext cx="256032" cy="256032"/>
           </a:xfrm>
           <a:prstGeom prst="rect">
@@ -11226,8 +11226,8 @@
         </p:nvSpPr>
         <p:spPr>
           <a:xfrm>
-            <a:off x="5774436" y="1920240"/>
-            <a:ext cx="1120140" cy="182880"/>
+            <a:off x="5733288" y="1920240"/>
+            <a:ext cx="1078992" cy="182880"/>
           </a:xfrm>
           <a:prstGeom prst="rect">
             <a:avLst/>
@@ -11267,8 +11267,8 @@
         </p:nvSpPr>
         <p:spPr>
           <a:xfrm>
-            <a:off x="5774436" y="2103120"/>
-            <a:ext cx="1120140" cy="384048"/>
+            <a:off x="5733288" y="2103120"/>
+            <a:ext cx="1078992" cy="384048"/>
           </a:xfrm>
           <a:prstGeom prst="rect">
             <a:avLst/>
@@ -11276,7 +11276,7 @@
           <a:noFill/>
         </p:spPr>
         <p:txBody>
-          <a:bodyPr wrap="square" anchor="ctr" lIns="0" rIns="0" tIns="0" bIns="0">
+          <a:bodyPr wrap="square" anchor="ctr" lIns="27432" rIns="27432" tIns="27432" bIns="27432">
             <a:spAutoFit/>
           </a:bodyPr>
           <a:lstStyle/>
@@ -11287,7 +11287,7 @@
               </a:lnSpc>
             </a:pPr>
             <a:r>
-              <a:rPr sz="800" b="0" i="0">
+              <a:rPr sz="850" b="0" i="0">
                 <a:solidFill>
                   <a:srgbClr val="1B2330"/>
                 </a:solidFill>
@@ -11305,7 +11305,7 @@
               </a:lnSpc>
             </a:pPr>
             <a:r>
-              <a:rPr sz="800" b="0" i="0">
+              <a:rPr sz="850" b="0" i="0">
                 <a:solidFill>
                   <a:srgbClr val="1B2330"/>
                 </a:solidFill>
@@ -11326,7 +11326,7 @@
         </p:nvSpPr>
         <p:spPr>
           <a:xfrm>
-            <a:off x="6922008" y="1956816"/>
+            <a:off x="6839712" y="1956816"/>
             <a:ext cx="73152" cy="164592"/>
           </a:xfrm>
           <a:prstGeom prst="chevron">
@@ -11356,8 +11356,8 @@
         </p:nvSpPr>
         <p:spPr>
           <a:xfrm>
-            <a:off x="7022592" y="1554480"/>
-            <a:ext cx="1120140" cy="969264"/>
+            <a:off x="6940296" y="1554480"/>
+            <a:ext cx="1078992" cy="969264"/>
           </a:xfrm>
           <a:prstGeom prst="roundRect">
             <a:avLst>
@@ -11388,7 +11388,7 @@
         </p:nvSpPr>
         <p:spPr>
           <a:xfrm>
-            <a:off x="7454646" y="1627632"/>
+            <a:off x="7351776" y="1627632"/>
             <a:ext cx="256032" cy="256032"/>
           </a:xfrm>
           <a:prstGeom prst="ellipse">
@@ -11416,7 +11416,7 @@
         </p:nvSpPr>
         <p:spPr>
           <a:xfrm>
-            <a:off x="7454646" y="1627632"/>
+            <a:off x="7351776" y="1627632"/>
             <a:ext cx="256032" cy="256032"/>
           </a:xfrm>
           <a:prstGeom prst="rect">
@@ -11457,8 +11457,8 @@
         </p:nvSpPr>
         <p:spPr>
           <a:xfrm>
-            <a:off x="7022592" y="1920240"/>
-            <a:ext cx="1120140" cy="182880"/>
+            <a:off x="6940296" y="1920240"/>
+            <a:ext cx="1078992" cy="182880"/>
           </a:xfrm>
           <a:prstGeom prst="rect">
             <a:avLst/>
@@ -11498,8 +11498,8 @@
         </p:nvSpPr>
         <p:spPr>
           <a:xfrm>
-            <a:off x="7022592" y="2103120"/>
-            <a:ext cx="1120140" cy="384048"/>
+            <a:off x="6940296" y="2103120"/>
+            <a:ext cx="1078992" cy="384048"/>
           </a:xfrm>
           <a:prstGeom prst="rect">
             <a:avLst/>
@@ -11507,7 +11507,7 @@
           <a:noFill/>
         </p:spPr>
         <p:txBody>
-          <a:bodyPr wrap="square" anchor="ctr" lIns="0" rIns="0" tIns="0" bIns="0">
+          <a:bodyPr wrap="square" anchor="ctr" lIns="27432" rIns="27432" tIns="27432" bIns="27432">
             <a:spAutoFit/>
           </a:bodyPr>
           <a:lstStyle/>
@@ -11518,7 +11518,7 @@
               </a:lnSpc>
             </a:pPr>
             <a:r>
-              <a:rPr sz="800" b="0" i="0">
+              <a:rPr sz="850" b="0" i="0">
                 <a:solidFill>
                   <a:srgbClr val="1B2330"/>
                 </a:solidFill>
@@ -11536,7 +11536,7 @@
               </a:lnSpc>
             </a:pPr>
             <a:r>
-              <a:rPr sz="800" b="0" i="0">
+              <a:rPr sz="850" b="0" i="0">
                 <a:solidFill>
                   <a:srgbClr val="1B2330"/>
                 </a:solidFill>
@@ -11557,7 +11557,7 @@
         </p:nvSpPr>
         <p:spPr>
           <a:xfrm>
-            <a:off x="8170164" y="1956816"/>
+            <a:off x="8046720" y="1956816"/>
             <a:ext cx="73152" cy="164592"/>
           </a:xfrm>
           <a:prstGeom prst="chevron">
@@ -11587,8 +11587,8 @@
         </p:nvSpPr>
         <p:spPr>
           <a:xfrm>
-            <a:off x="8270748" y="1554480"/>
-            <a:ext cx="1120140" cy="969264"/>
+            <a:off x="8147304" y="1554480"/>
+            <a:ext cx="1325880" cy="969264"/>
           </a:xfrm>
           <a:prstGeom prst="roundRect">
             <a:avLst>
@@ -11619,7 +11619,7 @@
         </p:nvSpPr>
         <p:spPr>
           <a:xfrm>
-            <a:off x="8702802" y="1627632"/>
+            <a:off x="8682228" y="1627632"/>
             <a:ext cx="256032" cy="256032"/>
           </a:xfrm>
           <a:prstGeom prst="ellipse">
@@ -11647,7 +11647,7 @@
         </p:nvSpPr>
         <p:spPr>
           <a:xfrm>
-            <a:off x="8702802" y="1627632"/>
+            <a:off x="8682228" y="1627632"/>
             <a:ext cx="256032" cy="256032"/>
           </a:xfrm>
           <a:prstGeom prst="rect">
@@ -11688,8 +11688,8 @@
         </p:nvSpPr>
         <p:spPr>
           <a:xfrm>
-            <a:off x="8270748" y="1920240"/>
-            <a:ext cx="1120140" cy="182880"/>
+            <a:off x="8147304" y="1920240"/>
+            <a:ext cx="1325880" cy="182880"/>
           </a:xfrm>
           <a:prstGeom prst="rect">
             <a:avLst/>
@@ -11729,8 +11729,8 @@
         </p:nvSpPr>
         <p:spPr>
           <a:xfrm>
-            <a:off x="8270748" y="2103120"/>
-            <a:ext cx="1120140" cy="384048"/>
+            <a:off x="8147304" y="2103120"/>
+            <a:ext cx="1325880" cy="384048"/>
           </a:xfrm>
           <a:prstGeom prst="rect">
             <a:avLst/>
@@ -11738,7 +11738,7 @@
           <a:noFill/>
         </p:spPr>
         <p:txBody>
-          <a:bodyPr wrap="square" anchor="ctr" lIns="0" rIns="0" tIns="0" bIns="0">
+          <a:bodyPr wrap="square" anchor="ctr" lIns="27432" rIns="27432" tIns="27432" bIns="27432">
             <a:spAutoFit/>
           </a:bodyPr>
           <a:lstStyle/>
@@ -11749,7 +11749,7 @@
               </a:lnSpc>
             </a:pPr>
             <a:r>
-              <a:rPr sz="800" b="0" i="0">
+              <a:rPr sz="850" b="0" i="0">
                 <a:solidFill>
                   <a:srgbClr val="FFFFFF"/>
                 </a:solidFill>
@@ -11767,7 +11767,7 @@
               </a:lnSpc>
             </a:pPr>
             <a:r>
-              <a:rPr sz="800" b="0" i="0">
+              <a:rPr sz="850" b="0" i="0">
                 <a:solidFill>
                   <a:srgbClr val="FFFFFF"/>
                 </a:solidFill>
@@ -11788,7 +11788,7 @@
         </p:nvSpPr>
         <p:spPr>
           <a:xfrm>
-            <a:off x="9418320" y="1956816"/>
+            <a:off x="9500615" y="1956816"/>
             <a:ext cx="73152" cy="164592"/>
           </a:xfrm>
           <a:prstGeom prst="chevron">
@@ -11818,8 +11818,8 @@
         </p:nvSpPr>
         <p:spPr>
           <a:xfrm>
-            <a:off x="9518904" y="1554480"/>
-            <a:ext cx="1120140" cy="969264"/>
+            <a:off x="9601200" y="1554480"/>
+            <a:ext cx="1078992" cy="969264"/>
           </a:xfrm>
           <a:prstGeom prst="roundRect">
             <a:avLst>
@@ -11850,7 +11850,7 @@
         </p:nvSpPr>
         <p:spPr>
           <a:xfrm>
-            <a:off x="9950958" y="1627632"/>
+            <a:off x="10012680" y="1627632"/>
             <a:ext cx="256032" cy="256032"/>
           </a:xfrm>
           <a:prstGeom prst="ellipse">
@@ -11878,7 +11878,7 @@
         </p:nvSpPr>
         <p:spPr>
           <a:xfrm>
-            <a:off x="9950958" y="1627632"/>
+            <a:off x="10012680" y="1627632"/>
             <a:ext cx="256032" cy="256032"/>
           </a:xfrm>
           <a:prstGeom prst="rect">
@@ -11919,8 +11919,8 @@
         </p:nvSpPr>
         <p:spPr>
           <a:xfrm>
-            <a:off x="9518904" y="1920240"/>
-            <a:ext cx="1120140" cy="182880"/>
+            <a:off x="9601200" y="1920240"/>
+            <a:ext cx="1078992" cy="182880"/>
           </a:xfrm>
           <a:prstGeom prst="rect">
             <a:avLst/>
@@ -11960,8 +11960,8 @@
         </p:nvSpPr>
         <p:spPr>
           <a:xfrm>
-            <a:off x="9518904" y="2103120"/>
-            <a:ext cx="1120140" cy="384048"/>
+            <a:off x="9601200" y="2103120"/>
+            <a:ext cx="1078992" cy="384048"/>
           </a:xfrm>
           <a:prstGeom prst="rect">
             <a:avLst/>
@@ -11969,7 +11969,7 @@
           <a:noFill/>
         </p:spPr>
         <p:txBody>
-          <a:bodyPr wrap="square" anchor="ctr" lIns="0" rIns="0" tIns="0" bIns="0">
+          <a:bodyPr wrap="square" anchor="ctr" lIns="27432" rIns="27432" tIns="27432" bIns="27432">
             <a:spAutoFit/>
           </a:bodyPr>
           <a:lstStyle/>
@@ -11980,7 +11980,7 @@
               </a:lnSpc>
             </a:pPr>
             <a:r>
-              <a:rPr sz="800" b="0" i="0">
+              <a:rPr sz="850" b="0" i="0">
                 <a:solidFill>
                   <a:srgbClr val="1B2330"/>
                 </a:solidFill>
@@ -11998,7 +11998,7 @@
               </a:lnSpc>
             </a:pPr>
             <a:r>
-              <a:rPr sz="800" b="0" i="0">
+              <a:rPr sz="850" b="0" i="0">
                 <a:solidFill>
                   <a:srgbClr val="1B2330"/>
                 </a:solidFill>
@@ -12019,7 +12019,7 @@
         </p:nvSpPr>
         <p:spPr>
           <a:xfrm>
-            <a:off x="10666476" y="1956816"/>
+            <a:off x="10707624" y="1956816"/>
             <a:ext cx="73152" cy="164592"/>
           </a:xfrm>
           <a:prstGeom prst="chevron">
@@ -12049,8 +12049,8 @@
         </p:nvSpPr>
         <p:spPr>
           <a:xfrm>
-            <a:off x="10767060" y="1554480"/>
-            <a:ext cx="1120140" cy="969264"/>
+            <a:off x="10808208" y="1554480"/>
+            <a:ext cx="1078992" cy="969264"/>
           </a:xfrm>
           <a:prstGeom prst="roundRect">
             <a:avLst>
@@ -12081,7 +12081,7 @@
         </p:nvSpPr>
         <p:spPr>
           <a:xfrm>
-            <a:off x="11199114" y="1627632"/>
+            <a:off x="11219688" y="1627632"/>
             <a:ext cx="256032" cy="256032"/>
           </a:xfrm>
           <a:prstGeom prst="ellipse">
@@ -12109,7 +12109,7 @@
         </p:nvSpPr>
         <p:spPr>
           <a:xfrm>
-            <a:off x="11199114" y="1627632"/>
+            <a:off x="11219688" y="1627632"/>
             <a:ext cx="256032" cy="256032"/>
           </a:xfrm>
           <a:prstGeom prst="rect">
@@ -12150,8 +12150,8 @@
         </p:nvSpPr>
         <p:spPr>
           <a:xfrm>
-            <a:off x="10767060" y="1920240"/>
-            <a:ext cx="1120140" cy="182880"/>
+            <a:off x="10808208" y="1920240"/>
+            <a:ext cx="1078992" cy="182880"/>
           </a:xfrm>
           <a:prstGeom prst="rect">
             <a:avLst/>
@@ -12191,8 +12191,8 @@
         </p:nvSpPr>
         <p:spPr>
           <a:xfrm>
-            <a:off x="10767060" y="2103120"/>
-            <a:ext cx="1120140" cy="384048"/>
+            <a:off x="10808208" y="2103120"/>
+            <a:ext cx="1078992" cy="384048"/>
           </a:xfrm>
           <a:prstGeom prst="rect">
             <a:avLst/>
@@ -12200,7 +12200,7 @@
           <a:noFill/>
         </p:spPr>
         <p:txBody>
-          <a:bodyPr wrap="square" anchor="ctr" lIns="0" rIns="0" tIns="0" bIns="0">
+          <a:bodyPr wrap="square" anchor="ctr" lIns="27432" rIns="27432" tIns="27432" bIns="27432">
             <a:spAutoFit/>
           </a:bodyPr>
           <a:lstStyle/>
@@ -12211,7 +12211,7 @@
               </a:lnSpc>
             </a:pPr>
             <a:r>
-              <a:rPr sz="800" b="0" i="0">
+              <a:rPr sz="850" b="0" i="0">
                 <a:solidFill>
                   <a:srgbClr val="1B2330"/>
                 </a:solidFill>
@@ -12229,7 +12229,7 @@
               </a:lnSpc>
             </a:pPr>
             <a:r>
-              <a:rPr sz="800" b="0" i="0">
+              <a:rPr sz="850" b="0" i="0">
                 <a:solidFill>
                   <a:srgbClr val="1B2330"/>
                 </a:solidFill>
@@ -16165,7 +16165,7 @@
               </a:lnSpc>
             </a:pPr>
             <a:r>
-              <a:rPr sz="750" b="1" i="0">
+              <a:rPr sz="800" b="1" i="0">
                 <a:solidFill>
                   <a:srgbClr val="FFFFFF"/>
                 </a:solidFill>
@@ -16277,7 +16277,7 @@
               </a:lnSpc>
             </a:pPr>
             <a:r>
-              <a:rPr sz="750" b="1" i="0">
+              <a:rPr sz="800" b="1" i="0">
                 <a:solidFill>
                   <a:srgbClr val="FFFFFF"/>
                 </a:solidFill>
@@ -18277,7 +18277,7 @@
       </p:sp>
       <p:pic>
         <p:nvPicPr>
-          <p:cNvPr id="17417" name="Picture 17416" descr="tornado-7FD3E0.png"/>
+          <p:cNvPr id="17417" name="Picture 17416" descr="cloud-lightning-7FD3E0.png"/>
           <p:cNvPicPr>
             <a:picLocks noChangeAspect="1"/>
           </p:cNvPicPr>

</xml_diff>

<commit_message>
deck: slide 5 bottom row of three ThermalTrace-style action cards
Replaces the three small prototype chips with a full-width row of equal
rounded cards (icon badge, bold teal heading, one-line description):
Click any cell / Argo overlay / Export, using the approved wording.
Key Outcome moves into the right column under the screenshot caption so the
row fits above the SIH footer; no other slide or text changes.

Co-Authored-By: Claude Opus 5.5 <noreply@anthropic.com>
Claude-Session: https://claude.ai/code/session_011ZpLQrPqPcimbyYNKERyYb
</commit_message>
<xml_diff>
--- a/deliverables/OceanSight_SIH2026_Idea_Submission.pptx
+++ b/deliverables/OceanSight_SIH2026_Idea_Submission.pptx
@@ -19465,8 +19465,224 @@
         </p:nvSpPr>
         <p:spPr>
           <a:xfrm>
-            <a:off x="320040" y="5577840"/>
-            <a:ext cx="6172200" cy="640080"/>
+            <a:off x="6766560" y="1188720"/>
+            <a:ext cx="274320" cy="274320"/>
+          </a:xfrm>
+          <a:prstGeom prst="roundRect">
+            <a:avLst>
+              <a:gd name="adj" fmla="val 22000"/>
+            </a:avLst>
+          </a:prstGeom>
+          <a:solidFill>
+            <a:srgbClr val="0E869A"/>
+          </a:solidFill>
+          <a:ln>
+            <a:noFill/>
+          </a:ln>
+          <a:effectLst/>
+        </p:spPr>
+        <p:txBody>
+          <a:bodyPr rtlCol="0" anchor="ctr"/>
+          <a:lstStyle/>
+          <a:p/>
+        </p:txBody>
+      </p:sp>
+      <p:pic>
+        <p:nvPicPr>
+          <p:cNvPr id="17450" name="Picture 17449" descr="monitor-FFFFFF.png"/>
+          <p:cNvPicPr>
+            <a:picLocks noChangeAspect="1"/>
+          </p:cNvPicPr>
+          <p:nvPr/>
+        </p:nvPicPr>
+        <p:blipFill>
+          <a:blip r:embed="rId16"/>
+          <a:stretch>
+            <a:fillRect/>
+          </a:stretch>
+        </p:blipFill>
+        <p:spPr>
+          <a:xfrm>
+            <a:off x="6821424" y="1243584"/>
+            <a:ext cx="164592" cy="164592"/>
+          </a:xfrm>
+          <a:prstGeom prst="rect">
+            <a:avLst/>
+          </a:prstGeom>
+        </p:spPr>
+      </p:pic>
+      <p:sp>
+        <p:nvSpPr>
+          <p:cNvPr id="17451" name="TextBox 17450"/>
+          <p:cNvSpPr txBox="1"/>
+          <p:nvPr/>
+        </p:nvSpPr>
+        <p:spPr>
+          <a:xfrm>
+            <a:off x="7114032" y="1170432"/>
+            <a:ext cx="4773168" cy="310896"/>
+          </a:xfrm>
+          <a:prstGeom prst="rect">
+            <a:avLst/>
+          </a:prstGeom>
+          <a:noFill/>
+        </p:spPr>
+        <p:txBody>
+          <a:bodyPr wrap="square" anchor="ctr" lIns="9144" rIns="9144" tIns="9144" bIns="9144">
+            <a:spAutoFit/>
+          </a:bodyPr>
+          <a:lstStyle/>
+          <a:p>
+            <a:pPr algn="l">
+              <a:lnSpc>
+                <a:spcPct val="100000"/>
+              </a:lnSpc>
+            </a:pPr>
+            <a:r>
+              <a:rPr sz="1300" b="1" i="0">
+                <a:solidFill>
+                  <a:srgbClr val="0B2F4E"/>
+                </a:solidFill>
+                <a:latin typeface="Arial"/>
+                <a:ea typeface="Arial"/>
+                <a:cs typeface="Arial"/>
+              </a:rPr>
+              <a:t>Working prototype</a:t>
+            </a:r>
+            <a:r>
+              <a:rPr sz="1000" b="0" i="0">
+                <a:solidFill>
+                  <a:srgbClr val="556578"/>
+                </a:solidFill>
+                <a:latin typeface="Arial"/>
+                <a:ea typeface="Arial"/>
+                <a:cs typeface="Arial"/>
+              </a:rPr>
+              <a:t>   real event, held-out year</a:t>
+            </a:r>
+          </a:p>
+        </p:txBody>
+      </p:sp>
+      <p:pic>
+        <p:nvPicPr>
+          <p:cNvPr id="17452" name="Picture 17451" descr="fuel_crop_215790.png"/>
+          <p:cNvPicPr>
+            <a:picLocks noChangeAspect="1"/>
+          </p:cNvPicPr>
+          <p:nvPr/>
+        </p:nvPicPr>
+        <p:blipFill>
+          <a:blip r:embed="rId17"/>
+          <a:stretch>
+            <a:fillRect/>
+          </a:stretch>
+        </p:blipFill>
+        <p:spPr>
+          <a:xfrm>
+            <a:off x="6766560" y="1554480"/>
+            <a:ext cx="2505456" cy="2557653"/>
+          </a:xfrm>
+          <a:prstGeom prst="rect">
+            <a:avLst/>
+          </a:prstGeom>
+          <a:ln w="9525">
+            <a:solidFill>
+              <a:srgbClr val="C9D6E2"/>
+            </a:solidFill>
+          </a:ln>
+        </p:spPr>
+      </p:pic>
+      <p:pic>
+        <p:nvPicPr>
+          <p:cNvPr id="17453" name="Picture 17452" descr="fuel_crop_607028.png"/>
+          <p:cNvPicPr>
+            <a:picLocks noChangeAspect="1"/>
+          </p:cNvPicPr>
+          <p:nvPr/>
+        </p:nvPicPr>
+        <p:blipFill>
+          <a:blip r:embed="rId18"/>
+          <a:stretch>
+            <a:fillRect/>
+          </a:stretch>
+        </p:blipFill>
+        <p:spPr>
+          <a:xfrm>
+            <a:off x="9381744" y="1554480"/>
+            <a:ext cx="2505456" cy="2664493"/>
+          </a:xfrm>
+          <a:prstGeom prst="rect">
+            <a:avLst/>
+          </a:prstGeom>
+          <a:ln w="9525">
+            <a:solidFill>
+              <a:srgbClr val="C9D6E2"/>
+            </a:solidFill>
+          </a:ln>
+        </p:spPr>
+      </p:pic>
+      <p:sp>
+        <p:nvSpPr>
+          <p:cNvPr id="17454" name="TextBox 17453"/>
+          <p:cNvSpPr txBox="1"/>
+          <p:nvPr/>
+        </p:nvSpPr>
+        <p:spPr>
+          <a:xfrm>
+            <a:off x="6766560" y="4273837"/>
+            <a:ext cx="5120640" cy="499330"/>
+          </a:xfrm>
+          <a:prstGeom prst="rect">
+            <a:avLst/>
+          </a:prstGeom>
+          <a:noFill/>
+        </p:spPr>
+        <p:txBody>
+          <a:bodyPr wrap="square" anchor="ctr" lIns="9144" rIns="9144" tIns="9144" bIns="9144">
+            <a:spAutoFit/>
+          </a:bodyPr>
+          <a:lstStyle/>
+          <a:p>
+            <a:pPr algn="l">
+              <a:lnSpc>
+                <a:spcPct val="100000"/>
+              </a:lnSpc>
+            </a:pPr>
+            <a:r>
+              <a:rPr sz="950" b="1" i="0">
+                <a:solidFill>
+                  <a:srgbClr val="0B2F4E"/>
+                </a:solidFill>
+                <a:latin typeface="Arial"/>
+                <a:ea typeface="Arial"/>
+                <a:cs typeface="Arial"/>
+              </a:rPr>
+              <a:t>Cyclone Fuel Gauge — </a:t>
+            </a:r>
+            <a:r>
+              <a:rPr sz="950" b="0" i="0">
+                <a:solidFill>
+                  <a:srgbClr val="556578"/>
+                </a:solidFill>
+                <a:latin typeface="Arial"/>
+                <a:ea typeface="Arial"/>
+                <a:cs typeface="Arial"/>
+              </a:rPr>
+              <a:t>reconstructed TCHP along Cyclone Mocha's real IBTrACS track (May 2023, ocean state 2 days before passage): 52.7–102 kJ/cm² over the ocean, above the 50 kJ/cm² level commonly linked to intensification. Prototype output, not an operational forecast.</a:t>
+            </a:r>
+          </a:p>
+        </p:txBody>
+      </p:sp>
+      <p:sp>
+        <p:nvSpPr>
+          <p:cNvPr id="17455" name="Rounded Rectangle 17454"/>
+          <p:cNvSpPr/>
+          <p:nvPr/>
+        </p:nvSpPr>
+        <p:spPr>
+          <a:xfrm>
+            <a:off x="6766560" y="4828032"/>
+            <a:ext cx="5120640" cy="640080"/>
           </a:xfrm>
           <a:prstGeom prst="roundRect">
             <a:avLst>
@@ -19489,13 +19705,13 @@
       </p:sp>
       <p:sp>
         <p:nvSpPr>
-          <p:cNvPr id="17450" name="Rounded Rectangle 17449"/>
+          <p:cNvPr id="17456" name="Rounded Rectangle 17455"/>
           <p:cNvSpPr/>
           <p:nvPr/>
         </p:nvSpPr>
         <p:spPr>
           <a:xfrm>
-            <a:off x="466344" y="5715000"/>
+            <a:off x="6912864" y="4965192"/>
             <a:ext cx="365760" cy="365760"/>
           </a:xfrm>
           <a:prstGeom prst="roundRect">
@@ -19519,21 +19735,21 @@
       </p:sp>
       <p:pic>
         <p:nvPicPr>
-          <p:cNvPr id="17451" name="Picture 17450" descr="target-FFFFFF.png"/>
+          <p:cNvPr id="17457" name="Picture 17456" descr="target-FFFFFF.png"/>
           <p:cNvPicPr>
             <a:picLocks noChangeAspect="1"/>
           </p:cNvPicPr>
           <p:nvPr/>
         </p:nvPicPr>
         <p:blipFill>
-          <a:blip r:embed="rId16"/>
+          <a:blip r:embed="rId19"/>
           <a:stretch>
             <a:fillRect/>
           </a:stretch>
         </p:blipFill>
         <p:spPr>
           <a:xfrm>
-            <a:off x="539496" y="5788152"/>
+            <a:off x="6986016" y="5038344"/>
             <a:ext cx="219456" cy="219456"/>
           </a:xfrm>
           <a:prstGeom prst="rect">
@@ -19543,14 +19759,14 @@
       </p:pic>
       <p:sp>
         <p:nvSpPr>
-          <p:cNvPr id="17452" name="TextBox 17451"/>
+          <p:cNvPr id="17458" name="TextBox 17457"/>
           <p:cNvSpPr txBox="1"/>
           <p:nvPr/>
         </p:nvSpPr>
         <p:spPr>
           <a:xfrm>
-            <a:off x="941832" y="5577840"/>
-            <a:ext cx="5440680" cy="640080"/>
+            <a:off x="7388352" y="4828032"/>
+            <a:ext cx="4389120" cy="640080"/>
           </a:xfrm>
           <a:prstGeom prst="rect">
             <a:avLst/>
@@ -19587,7 +19803,7 @@
               </a:lnSpc>
             </a:pPr>
             <a:r>
-              <a:rPr sz="1150" b="1" i="0">
+              <a:rPr sz="1100" b="1" i="0">
                 <a:solidFill>
                   <a:srgbClr val="FFFFFF"/>
                 </a:solidFill>
@@ -19595,21 +19811,71 @@
                 <a:ea typeface="Arial"/>
                 <a:cs typeface="Arial"/>
               </a:rPr>
-              <a:t>full-basin subsurface view · daily · 0–1000 m · with measured confidence</a:t>
-            </a:r>
-          </a:p>
-        </p:txBody>
-      </p:sp>
-      <p:sp>
-        <p:nvSpPr>
-          <p:cNvPr id="17453" name="Rounded Rectangle 17452"/>
+              <a:t>full-basin subsurface view · daily ·</a:t>
+            </a:r>
+          </a:p>
+          <a:p>
+            <a:pPr algn="l">
+              <a:lnSpc>
+                <a:spcPct val="100000"/>
+              </a:lnSpc>
+            </a:pPr>
+            <a:r>
+              <a:rPr sz="1100" b="1" i="0">
+                <a:solidFill>
+                  <a:srgbClr val="FFFFFF"/>
+                </a:solidFill>
+                <a:latin typeface="Arial"/>
+                <a:ea typeface="Arial"/>
+                <a:cs typeface="Arial"/>
+              </a:rPr>
+              <a:t>0–1000 m · with measured confidence</a:t>
+            </a:r>
+          </a:p>
+        </p:txBody>
+      </p:sp>
+      <p:sp>
+        <p:nvSpPr>
+          <p:cNvPr id="17459" name="Rounded Rectangle 17458"/>
           <p:cNvSpPr/>
           <p:nvPr/>
         </p:nvSpPr>
         <p:spPr>
           <a:xfrm>
-            <a:off x="6766560" y="1188720"/>
-            <a:ext cx="274320" cy="274320"/>
+            <a:off x="320040" y="5577840"/>
+            <a:ext cx="3733799" cy="658368"/>
+          </a:xfrm>
+          <a:prstGeom prst="roundRect">
+            <a:avLst>
+              <a:gd name="adj" fmla="val 13888"/>
+            </a:avLst>
+          </a:prstGeom>
+          <a:solidFill>
+            <a:srgbClr val="EDF4FA"/>
+          </a:solidFill>
+          <a:ln w="15875">
+            <a:solidFill>
+              <a:srgbClr val="0B2F4E"/>
+            </a:solidFill>
+          </a:ln>
+          <a:effectLst/>
+        </p:spPr>
+        <p:txBody>
+          <a:bodyPr rtlCol="0" anchor="ctr"/>
+          <a:lstStyle/>
+          <a:p/>
+        </p:txBody>
+      </p:sp>
+      <p:sp>
+        <p:nvSpPr>
+          <p:cNvPr id="17460" name="Rounded Rectangle 17459"/>
+          <p:cNvSpPr/>
+          <p:nvPr/>
+        </p:nvSpPr>
+        <p:spPr>
+          <a:xfrm>
+            <a:off x="466344" y="5715000"/>
+            <a:ext cx="384048" cy="384048"/>
           </a:xfrm>
           <a:prstGeom prst="roundRect">
             <a:avLst>
@@ -19632,257 +19898,7 @@
       </p:sp>
       <p:pic>
         <p:nvPicPr>
-          <p:cNvPr id="17454" name="Picture 17453" descr="monitor-FFFFFF.png"/>
-          <p:cNvPicPr>
-            <a:picLocks noChangeAspect="1"/>
-          </p:cNvPicPr>
-          <p:nvPr/>
-        </p:nvPicPr>
-        <p:blipFill>
-          <a:blip r:embed="rId17"/>
-          <a:stretch>
-            <a:fillRect/>
-          </a:stretch>
-        </p:blipFill>
-        <p:spPr>
-          <a:xfrm>
-            <a:off x="6821424" y="1243584"/>
-            <a:ext cx="164592" cy="164592"/>
-          </a:xfrm>
-          <a:prstGeom prst="rect">
-            <a:avLst/>
-          </a:prstGeom>
-        </p:spPr>
-      </p:pic>
-      <p:sp>
-        <p:nvSpPr>
-          <p:cNvPr id="17455" name="TextBox 17454"/>
-          <p:cNvSpPr txBox="1"/>
-          <p:nvPr/>
-        </p:nvSpPr>
-        <p:spPr>
-          <a:xfrm>
-            <a:off x="7114032" y="1170432"/>
-            <a:ext cx="4773168" cy="310896"/>
-          </a:xfrm>
-          <a:prstGeom prst="rect">
-            <a:avLst/>
-          </a:prstGeom>
-          <a:noFill/>
-        </p:spPr>
-        <p:txBody>
-          <a:bodyPr wrap="square" anchor="ctr" lIns="9144" rIns="9144" tIns="9144" bIns="9144">
-            <a:spAutoFit/>
-          </a:bodyPr>
-          <a:lstStyle/>
-          <a:p>
-            <a:pPr algn="l">
-              <a:lnSpc>
-                <a:spcPct val="100000"/>
-              </a:lnSpc>
-            </a:pPr>
-            <a:r>
-              <a:rPr sz="1300" b="1" i="0">
-                <a:solidFill>
-                  <a:srgbClr val="0B2F4E"/>
-                </a:solidFill>
-                <a:latin typeface="Arial"/>
-                <a:ea typeface="Arial"/>
-                <a:cs typeface="Arial"/>
-              </a:rPr>
-              <a:t>Working prototype</a:t>
-            </a:r>
-            <a:r>
-              <a:rPr sz="1000" b="0" i="0">
-                <a:solidFill>
-                  <a:srgbClr val="556578"/>
-                </a:solidFill>
-                <a:latin typeface="Arial"/>
-                <a:ea typeface="Arial"/>
-                <a:cs typeface="Arial"/>
-              </a:rPr>
-              <a:t>   real event, held-out year</a:t>
-            </a:r>
-          </a:p>
-        </p:txBody>
-      </p:sp>
-      <p:pic>
-        <p:nvPicPr>
-          <p:cNvPr id="17456" name="Picture 17455" descr="fuel_crop_215790.png"/>
-          <p:cNvPicPr>
-            <a:picLocks noChangeAspect="1"/>
-          </p:cNvPicPr>
-          <p:nvPr/>
-        </p:nvPicPr>
-        <p:blipFill>
-          <a:blip r:embed="rId18"/>
-          <a:stretch>
-            <a:fillRect/>
-          </a:stretch>
-        </p:blipFill>
-        <p:spPr>
-          <a:xfrm>
-            <a:off x="6766560" y="1554480"/>
-            <a:ext cx="2505456" cy="2557653"/>
-          </a:xfrm>
-          <a:prstGeom prst="rect">
-            <a:avLst/>
-          </a:prstGeom>
-          <a:ln w="9525">
-            <a:solidFill>
-              <a:srgbClr val="C9D6E2"/>
-            </a:solidFill>
-          </a:ln>
-        </p:spPr>
-      </p:pic>
-      <p:pic>
-        <p:nvPicPr>
-          <p:cNvPr id="17457" name="Picture 17456" descr="fuel_crop_607028.png"/>
-          <p:cNvPicPr>
-            <a:picLocks noChangeAspect="1"/>
-          </p:cNvPicPr>
-          <p:nvPr/>
-        </p:nvPicPr>
-        <p:blipFill>
-          <a:blip r:embed="rId19"/>
-          <a:stretch>
-            <a:fillRect/>
-          </a:stretch>
-        </p:blipFill>
-        <p:spPr>
-          <a:xfrm>
-            <a:off x="9381744" y="1554480"/>
-            <a:ext cx="2505456" cy="2664493"/>
-          </a:xfrm>
-          <a:prstGeom prst="rect">
-            <a:avLst/>
-          </a:prstGeom>
-          <a:ln w="9525">
-            <a:solidFill>
-              <a:srgbClr val="C9D6E2"/>
-            </a:solidFill>
-          </a:ln>
-        </p:spPr>
-      </p:pic>
-      <p:sp>
-        <p:nvSpPr>
-          <p:cNvPr id="17458" name="Rounded Rectangle 17457"/>
-          <p:cNvSpPr/>
-          <p:nvPr/>
-        </p:nvSpPr>
-        <p:spPr>
-          <a:xfrm>
-            <a:off x="6766560" y="4328701"/>
-            <a:ext cx="5120640" cy="1121122"/>
-          </a:xfrm>
-          <a:prstGeom prst="roundRect">
-            <a:avLst>
-              <a:gd name="adj" fmla="val 8156"/>
-            </a:avLst>
-          </a:prstGeom>
-          <a:solidFill>
-            <a:srgbClr val="F2F6F9"/>
-          </a:solidFill>
-          <a:ln w="12700">
-            <a:solidFill>
-              <a:srgbClr val="C9D6E2"/>
-            </a:solidFill>
-          </a:ln>
-          <a:effectLst/>
-        </p:spPr>
-        <p:txBody>
-          <a:bodyPr rtlCol="0" anchor="ctr"/>
-          <a:lstStyle/>
-          <a:p/>
-        </p:txBody>
-      </p:sp>
-      <p:sp>
-        <p:nvSpPr>
-          <p:cNvPr id="17459" name="TextBox 17458"/>
-          <p:cNvSpPr txBox="1"/>
-          <p:nvPr/>
-        </p:nvSpPr>
-        <p:spPr>
-          <a:xfrm>
-            <a:off x="6894576" y="4328701"/>
-            <a:ext cx="4864607" cy="1121122"/>
-          </a:xfrm>
-          <a:prstGeom prst="rect">
-            <a:avLst/>
-          </a:prstGeom>
-          <a:noFill/>
-        </p:spPr>
-        <p:txBody>
-          <a:bodyPr wrap="square" anchor="ctr" lIns="9144" rIns="9144" tIns="9144" bIns="9144">
-            <a:spAutoFit/>
-          </a:bodyPr>
-          <a:lstStyle/>
-          <a:p>
-            <a:pPr algn="l">
-              <a:lnSpc>
-                <a:spcPct val="100000"/>
-              </a:lnSpc>
-            </a:pPr>
-            <a:r>
-              <a:rPr sz="950" b="1" i="0">
-                <a:solidFill>
-                  <a:srgbClr val="0B2F4E"/>
-                </a:solidFill>
-                <a:latin typeface="Arial"/>
-                <a:ea typeface="Arial"/>
-                <a:cs typeface="Arial"/>
-              </a:rPr>
-              <a:t>Cyclone Fuel Gauge — </a:t>
-            </a:r>
-            <a:r>
-              <a:rPr sz="950" b="0" i="0">
-                <a:solidFill>
-                  <a:srgbClr val="556578"/>
-                </a:solidFill>
-                <a:latin typeface="Arial"/>
-                <a:ea typeface="Arial"/>
-                <a:cs typeface="Arial"/>
-              </a:rPr>
-              <a:t>reconstructed TCHP along Cyclone Mocha's real IBTrACS track (May 2023, ocean state 2 days before passage): 52.7–102 kJ/cm² over the ocean, above the 50 kJ/cm² level commonly linked to intensification. Prototype output, not an operational forecast.</a:t>
-            </a:r>
-          </a:p>
-        </p:txBody>
-      </p:sp>
-      <p:sp>
-        <p:nvSpPr>
-          <p:cNvPr id="17460" name="Rounded Rectangle 17459"/>
-          <p:cNvSpPr/>
-          <p:nvPr/>
-        </p:nvSpPr>
-        <p:spPr>
-          <a:xfrm>
-            <a:off x="6766560" y="5577840"/>
-            <a:ext cx="1633727" cy="640080"/>
-          </a:xfrm>
-          <a:prstGeom prst="roundRect">
-            <a:avLst>
-              <a:gd name="adj" fmla="val 14285"/>
-            </a:avLst>
-          </a:prstGeom>
-          <a:solidFill>
-            <a:srgbClr val="E3F3F6"/>
-          </a:solidFill>
-          <a:ln w="15875">
-            <a:solidFill>
-              <a:srgbClr val="0E869A"/>
-            </a:solidFill>
-          </a:ln>
-          <a:effectLst/>
-        </p:spPr>
-        <p:txBody>
-          <a:bodyPr rtlCol="0" anchor="ctr"/>
-          <a:lstStyle/>
-          <a:p/>
-        </p:txBody>
-      </p:sp>
-      <p:pic>
-        <p:nvPicPr>
-          <p:cNvPr id="17461" name="Picture 17460" descr="mouse-pointer-click-0E869A.png"/>
+          <p:cNvPr id="17461" name="Picture 17460" descr="mouse-pointer-click-FFFFFF.png"/>
           <p:cNvPicPr>
             <a:picLocks noChangeAspect="1"/>
           </p:cNvPicPr>
@@ -19896,8 +19912,8 @@
         </p:blipFill>
         <p:spPr>
           <a:xfrm>
-            <a:off x="6957568" y="5687568"/>
-            <a:ext cx="201168" cy="201168"/>
+            <a:off x="543153" y="5791809"/>
+            <a:ext cx="230428" cy="230428"/>
           </a:xfrm>
           <a:prstGeom prst="rect">
             <a:avLst/>
@@ -19912,8 +19928,8 @@
         </p:nvSpPr>
         <p:spPr>
           <a:xfrm>
-            <a:off x="7213600" y="5669279"/>
-            <a:ext cx="1178560" cy="237744"/>
+            <a:off x="978407" y="5650992"/>
+            <a:ext cx="2947416" cy="256032"/>
           </a:xfrm>
           <a:prstGeom prst="rect">
             <a:avLst/>
@@ -19921,7 +19937,7 @@
           <a:noFill/>
         </p:spPr>
         <p:txBody>
-          <a:bodyPr wrap="square" anchor="ctr" lIns="0" rIns="0" tIns="0" bIns="0">
+          <a:bodyPr wrap="square" anchor="ctr" lIns="9144" rIns="9144" tIns="9144" bIns="9144">
             <a:spAutoFit/>
           </a:bodyPr>
           <a:lstStyle/>
@@ -19932,7 +19948,7 @@
               </a:lnSpc>
             </a:pPr>
             <a:r>
-              <a:rPr sz="1000" b="1" i="0">
+              <a:rPr sz="1150" b="1" i="0">
                 <a:solidFill>
                   <a:srgbClr val="0E869A"/>
                 </a:solidFill>
@@ -19940,7 +19956,7 @@
                 <a:ea typeface="Arial"/>
                 <a:cs typeface="Arial"/>
               </a:rPr>
-              <a:t>Click any cell</a:t>
+              <a:t>CLICK ANY CELL</a:t>
             </a:r>
           </a:p>
         </p:txBody>
@@ -19953,8 +19969,8 @@
         </p:nvSpPr>
         <p:spPr>
           <a:xfrm>
-            <a:off x="6766560" y="5925312"/>
-            <a:ext cx="1633727" cy="219456"/>
+            <a:off x="978407" y="5925312"/>
+            <a:ext cx="2947416" cy="237744"/>
           </a:xfrm>
           <a:prstGeom prst="rect">
             <a:avLst/>
@@ -19967,13 +19983,13 @@
           </a:bodyPr>
           <a:lstStyle/>
           <a:p>
-            <a:pPr algn="ctr">
+            <a:pPr algn="l">
               <a:lnSpc>
                 <a:spcPct val="100000"/>
               </a:lnSpc>
             </a:pPr>
             <a:r>
-              <a:rPr sz="880" b="0" i="0">
+              <a:rPr sz="1000" b="0" i="0">
                 <a:solidFill>
                   <a:srgbClr val="1B2330"/>
                 </a:solidFill>
@@ -19981,7 +19997,7 @@
                 <a:ea typeface="Arial"/>
                 <a:cs typeface="Arial"/>
               </a:rPr>
-              <a:t>full 0–1000 m profile + σ</a:t>
+              <a:t>Full 0–1000 m temperature profile + uncertainty</a:t>
             </a:r>
           </a:p>
         </p:txBody>
@@ -19994,20 +20010,20 @@
         </p:nvSpPr>
         <p:spPr>
           <a:xfrm>
-            <a:off x="8510016" y="5577840"/>
-            <a:ext cx="1633727" cy="640080"/>
+            <a:off x="4236720" y="5577840"/>
+            <a:ext cx="3733799" cy="658368"/>
           </a:xfrm>
           <a:prstGeom prst="roundRect">
             <a:avLst>
-              <a:gd name="adj" fmla="val 14285"/>
+              <a:gd name="adj" fmla="val 13888"/>
             </a:avLst>
           </a:prstGeom>
           <a:solidFill>
-            <a:srgbClr val="E3F3F6"/>
+            <a:srgbClr val="EDF4FA"/>
           </a:solidFill>
           <a:ln w="15875">
             <a:solidFill>
-              <a:srgbClr val="0E869A"/>
+              <a:srgbClr val="0B2F4E"/>
             </a:solidFill>
           </a:ln>
           <a:effectLst/>
@@ -20018,9 +20034,39 @@
           <a:p/>
         </p:txBody>
       </p:sp>
+      <p:sp>
+        <p:nvSpPr>
+          <p:cNvPr id="17465" name="Rounded Rectangle 17464"/>
+          <p:cNvSpPr/>
+          <p:nvPr/>
+        </p:nvSpPr>
+        <p:spPr>
+          <a:xfrm>
+            <a:off x="4383024" y="5715000"/>
+            <a:ext cx="384048" cy="384048"/>
+          </a:xfrm>
+          <a:prstGeom prst="roundRect">
+            <a:avLst>
+              <a:gd name="adj" fmla="val 22000"/>
+            </a:avLst>
+          </a:prstGeom>
+          <a:solidFill>
+            <a:srgbClr val="0E869A"/>
+          </a:solidFill>
+          <a:ln>
+            <a:noFill/>
+          </a:ln>
+          <a:effectLst/>
+        </p:spPr>
+        <p:txBody>
+          <a:bodyPr rtlCol="0" anchor="ctr"/>
+          <a:lstStyle/>
+          <a:p/>
+        </p:txBody>
+      </p:sp>
       <p:pic>
         <p:nvPicPr>
-          <p:cNvPr id="17465" name="Picture 17464" descr="map-pin-0E869A.png"/>
+          <p:cNvPr id="17466" name="Picture 17465" descr="map-pin-FFFFFF.png"/>
           <p:cNvPicPr>
             <a:picLocks noChangeAspect="1"/>
           </p:cNvPicPr>
@@ -20034,8 +20080,8 @@
         </p:blipFill>
         <p:spPr>
           <a:xfrm>
-            <a:off x="8772144" y="5687568"/>
-            <a:ext cx="201168" cy="201168"/>
+            <a:off x="4459833" y="5791809"/>
+            <a:ext cx="230428" cy="230428"/>
           </a:xfrm>
           <a:prstGeom prst="rect">
             <a:avLst/>
@@ -20044,14 +20090,14 @@
       </p:pic>
       <p:sp>
         <p:nvSpPr>
-          <p:cNvPr id="17466" name="TextBox 17465"/>
+          <p:cNvPr id="17467" name="TextBox 17466"/>
           <p:cNvSpPr txBox="1"/>
           <p:nvPr/>
         </p:nvSpPr>
         <p:spPr>
           <a:xfrm>
-            <a:off x="9028176" y="5669279"/>
-            <a:ext cx="1036320" cy="237744"/>
+            <a:off x="4895087" y="5650992"/>
+            <a:ext cx="2947416" cy="256032"/>
           </a:xfrm>
           <a:prstGeom prst="rect">
             <a:avLst/>
@@ -20059,7 +20105,7 @@
           <a:noFill/>
         </p:spPr>
         <p:txBody>
-          <a:bodyPr wrap="square" anchor="ctr" lIns="0" rIns="0" tIns="0" bIns="0">
+          <a:bodyPr wrap="square" anchor="ctr" lIns="9144" rIns="9144" tIns="9144" bIns="9144">
             <a:spAutoFit/>
           </a:bodyPr>
           <a:lstStyle/>
@@ -20070,7 +20116,7 @@
               </a:lnSpc>
             </a:pPr>
             <a:r>
-              <a:rPr sz="1000" b="1" i="0">
+              <a:rPr sz="1150" b="1" i="0">
                 <a:solidFill>
                   <a:srgbClr val="0E869A"/>
                 </a:solidFill>
@@ -20078,21 +20124,21 @@
                 <a:ea typeface="Arial"/>
                 <a:cs typeface="Arial"/>
               </a:rPr>
-              <a:t>Argo overlay</a:t>
-            </a:r>
-          </a:p>
-        </p:txBody>
-      </p:sp>
-      <p:sp>
-        <p:nvSpPr>
-          <p:cNvPr id="17467" name="TextBox 17466"/>
+              <a:t>ARGO OVERLAY</a:t>
+            </a:r>
+          </a:p>
+        </p:txBody>
+      </p:sp>
+      <p:sp>
+        <p:nvSpPr>
+          <p:cNvPr id="17468" name="TextBox 17467"/>
           <p:cNvSpPr txBox="1"/>
           <p:nvPr/>
         </p:nvSpPr>
         <p:spPr>
           <a:xfrm>
-            <a:off x="8510016" y="5925312"/>
-            <a:ext cx="1633727" cy="219456"/>
+            <a:off x="4895087" y="5925312"/>
+            <a:ext cx="2947416" cy="237744"/>
           </a:xfrm>
           <a:prstGeom prst="rect">
             <a:avLst/>
@@ -20105,13 +20151,13 @@
           </a:bodyPr>
           <a:lstStyle/>
           <a:p>
-            <a:pPr algn="ctr">
+            <a:pPr algn="l">
               <a:lnSpc>
                 <a:spcPct val="100000"/>
               </a:lnSpc>
             </a:pPr>
             <a:r>
-              <a:rPr sz="880" b="0" i="0">
+              <a:rPr sz="1000" b="0" i="0">
                 <a:solidFill>
                   <a:srgbClr val="1B2330"/>
                 </a:solidFill>
@@ -20119,33 +20165,33 @@
                 <a:ea typeface="Arial"/>
                 <a:cs typeface="Arial"/>
               </a:rPr>
-              <a:t>nearest independent float</a:t>
-            </a:r>
-          </a:p>
-        </p:txBody>
-      </p:sp>
-      <p:sp>
-        <p:nvSpPr>
-          <p:cNvPr id="17468" name="Rounded Rectangle 17467"/>
+              <a:t>Compare with the nearest independent Argo float</a:t>
+            </a:r>
+          </a:p>
+        </p:txBody>
+      </p:sp>
+      <p:sp>
+        <p:nvSpPr>
+          <p:cNvPr id="17469" name="Rounded Rectangle 17468"/>
           <p:cNvSpPr/>
           <p:nvPr/>
         </p:nvSpPr>
         <p:spPr>
           <a:xfrm>
-            <a:off x="10253472" y="5577840"/>
-            <a:ext cx="1633727" cy="640080"/>
+            <a:off x="8153399" y="5577840"/>
+            <a:ext cx="3733799" cy="658368"/>
           </a:xfrm>
           <a:prstGeom prst="roundRect">
             <a:avLst>
-              <a:gd name="adj" fmla="val 14285"/>
+              <a:gd name="adj" fmla="val 13888"/>
             </a:avLst>
           </a:prstGeom>
           <a:solidFill>
-            <a:srgbClr val="E3F3F6"/>
+            <a:srgbClr val="EDF4FA"/>
           </a:solidFill>
           <a:ln w="15875">
             <a:solidFill>
-              <a:srgbClr val="0E869A"/>
+              <a:srgbClr val="0B2F4E"/>
             </a:solidFill>
           </a:ln>
           <a:effectLst/>
@@ -20156,9 +20202,39 @@
           <a:p/>
         </p:txBody>
       </p:sp>
+      <p:sp>
+        <p:nvSpPr>
+          <p:cNvPr id="17470" name="Rounded Rectangle 17469"/>
+          <p:cNvSpPr/>
+          <p:nvPr/>
+        </p:nvSpPr>
+        <p:spPr>
+          <a:xfrm>
+            <a:off x="8299704" y="5715000"/>
+            <a:ext cx="384048" cy="384048"/>
+          </a:xfrm>
+          <a:prstGeom prst="roundRect">
+            <a:avLst>
+              <a:gd name="adj" fmla="val 22000"/>
+            </a:avLst>
+          </a:prstGeom>
+          <a:solidFill>
+            <a:srgbClr val="0E869A"/>
+          </a:solidFill>
+          <a:ln>
+            <a:noFill/>
+          </a:ln>
+          <a:effectLst/>
+        </p:spPr>
+        <p:txBody>
+          <a:bodyPr rtlCol="0" anchor="ctr"/>
+          <a:lstStyle/>
+          <a:p/>
+        </p:txBody>
+      </p:sp>
       <p:pic>
         <p:nvPicPr>
-          <p:cNvPr id="17469" name="Picture 17468" descr="file-down-0E869A.png"/>
+          <p:cNvPr id="17471" name="Picture 17470" descr="file-down-FFFFFF.png"/>
           <p:cNvPicPr>
             <a:picLocks noChangeAspect="1"/>
           </p:cNvPicPr>
@@ -20172,8 +20248,8 @@
         </p:blipFill>
         <p:spPr>
           <a:xfrm>
-            <a:off x="10728960" y="5687568"/>
-            <a:ext cx="201168" cy="201168"/>
+            <a:off x="8376513" y="5791809"/>
+            <a:ext cx="230428" cy="230428"/>
           </a:xfrm>
           <a:prstGeom prst="rect">
             <a:avLst/>
@@ -20182,14 +20258,14 @@
       </p:pic>
       <p:sp>
         <p:nvSpPr>
-          <p:cNvPr id="17470" name="TextBox 17469"/>
+          <p:cNvPr id="17472" name="TextBox 17471"/>
           <p:cNvSpPr txBox="1"/>
           <p:nvPr/>
         </p:nvSpPr>
         <p:spPr>
           <a:xfrm>
-            <a:off x="10984991" y="5669279"/>
-            <a:ext cx="609600" cy="237744"/>
+            <a:off x="8811768" y="5650992"/>
+            <a:ext cx="2947416" cy="256032"/>
           </a:xfrm>
           <a:prstGeom prst="rect">
             <a:avLst/>
@@ -20197,7 +20273,7 @@
           <a:noFill/>
         </p:spPr>
         <p:txBody>
-          <a:bodyPr wrap="square" anchor="ctr" lIns="0" rIns="0" tIns="0" bIns="0">
+          <a:bodyPr wrap="square" anchor="ctr" lIns="9144" rIns="9144" tIns="9144" bIns="9144">
             <a:spAutoFit/>
           </a:bodyPr>
           <a:lstStyle/>
@@ -20208,7 +20284,7 @@
               </a:lnSpc>
             </a:pPr>
             <a:r>
-              <a:rPr sz="1000" b="1" i="0">
+              <a:rPr sz="1150" b="1" i="0">
                 <a:solidFill>
                   <a:srgbClr val="0E869A"/>
                 </a:solidFill>
@@ -20216,21 +20292,21 @@
                 <a:ea typeface="Arial"/>
                 <a:cs typeface="Arial"/>
               </a:rPr>
-              <a:t>Export</a:t>
-            </a:r>
-          </a:p>
-        </p:txBody>
-      </p:sp>
-      <p:sp>
-        <p:nvSpPr>
-          <p:cNvPr id="17471" name="TextBox 17470"/>
+              <a:t>EXPORT</a:t>
+            </a:r>
+          </a:p>
+        </p:txBody>
+      </p:sp>
+      <p:sp>
+        <p:nvSpPr>
+          <p:cNvPr id="17473" name="TextBox 17472"/>
           <p:cNvSpPr txBox="1"/>
           <p:nvPr/>
         </p:nvSpPr>
         <p:spPr>
           <a:xfrm>
-            <a:off x="10253472" y="5925312"/>
-            <a:ext cx="1633727" cy="219456"/>
+            <a:off x="8811768" y="5925312"/>
+            <a:ext cx="2947416" cy="237744"/>
           </a:xfrm>
           <a:prstGeom prst="rect">
             <a:avLst/>
@@ -20243,13 +20319,13 @@
           </a:bodyPr>
           <a:lstStyle/>
           <a:p>
-            <a:pPr algn="ctr">
+            <a:pPr algn="l">
               <a:lnSpc>
                 <a:spcPct val="100000"/>
               </a:lnSpc>
             </a:pPr>
             <a:r>
-              <a:rPr sz="880" b="0" i="0">
+              <a:rPr sz="1000" b="0" i="0">
                 <a:solidFill>
                   <a:srgbClr val="1B2330"/>
                 </a:solidFill>
@@ -20257,7 +20333,7 @@
                 <a:ea typeface="Arial"/>
                 <a:cs typeface="Arial"/>
               </a:rPr>
-              <a:t>PDF / CSV report per point</a:t>
+              <a:t>Generate PDF / CSV report for the selected point</a:t>
             </a:r>
           </a:p>
         </p:txBody>

</xml_diff>

<commit_message>
deck: slide 5 six cards in two rows (functionality + demo / live)
Row 1 keeps CLICK ANY CELL / ARGO OVERLAY / EXPORT unchanged. Row 2 adds
DEMO VIDEO / VIEW DEMO VIDEO (DRIVE) / TRY OCEANSIGHT LIVE in the
ThermalTrace link-box style. The repository has no demo, Drive or verified
live URL, so these cards ship unlinked; pass --demo-url / --drive-url /
--live-url to the builder to make them (and their headings) clickable.

To fit both rows above the footer: audience cards and benefit tiles are
slightly shorter (same font sizes) and the Cyclone Fuel Gauge screenshot is
reframed to a shorter height across the full column. Key Outcome, caption
and all other slides are unchanged.

Co-Authored-By: Claude Opus 5.5 <noreply@anthropic.com>
Claude-Session: https://claude.ai/code/session_011ZpLQrPqPcimbyYNKERyYb
</commit_message>
<xml_diff>
--- a/deliverables/OceanSight_SIH2026_Idea_Submission.pptx
+++ b/deliverables/OceanSight_SIH2026_Idea_Submission.pptx
@@ -18122,12 +18122,12 @@
         </p:nvSpPr>
         <p:spPr>
           <a:xfrm>
-            <a:off x="320040" y="1554480"/>
-            <a:ext cx="1440180" cy="950976"/>
+            <a:off x="320040" y="1517904"/>
+            <a:ext cx="1440180" cy="841248"/>
           </a:xfrm>
           <a:prstGeom prst="roundRect">
             <a:avLst>
-              <a:gd name="adj" fmla="val 9615"/>
+              <a:gd name="adj" fmla="val 10869"/>
             </a:avLst>
           </a:prstGeom>
           <a:solidFill>
@@ -18160,8 +18160,8 @@
         </p:blipFill>
         <p:spPr>
           <a:xfrm>
-            <a:off x="912114" y="1627632"/>
-            <a:ext cx="256032" cy="256032"/>
+            <a:off x="921257" y="1572768"/>
+            <a:ext cx="237744" cy="237744"/>
           </a:xfrm>
           <a:prstGeom prst="rect">
             <a:avLst/>
@@ -18176,8 +18176,8 @@
         </p:nvSpPr>
         <p:spPr>
           <a:xfrm>
-            <a:off x="320040" y="1901952"/>
-            <a:ext cx="1440180" cy="566928"/>
+            <a:off x="320040" y="1828800"/>
+            <a:ext cx="1440180" cy="512064"/>
           </a:xfrm>
           <a:prstGeom prst="rect">
             <a:avLst/>
@@ -18253,12 +18253,12 @@
         </p:nvSpPr>
         <p:spPr>
           <a:xfrm>
-            <a:off x="1897379" y="1554480"/>
-            <a:ext cx="1440180" cy="950976"/>
+            <a:off x="1897379" y="1517904"/>
+            <a:ext cx="1440180" cy="841248"/>
           </a:xfrm>
           <a:prstGeom prst="roundRect">
             <a:avLst>
-              <a:gd name="adj" fmla="val 9615"/>
+              <a:gd name="adj" fmla="val 10869"/>
             </a:avLst>
           </a:prstGeom>
           <a:solidFill>
@@ -18291,8 +18291,8 @@
         </p:blipFill>
         <p:spPr>
           <a:xfrm>
-            <a:off x="2489453" y="1627632"/>
-            <a:ext cx="256032" cy="256032"/>
+            <a:off x="2498598" y="1572768"/>
+            <a:ext cx="237744" cy="237744"/>
           </a:xfrm>
           <a:prstGeom prst="rect">
             <a:avLst/>
@@ -18307,8 +18307,8 @@
         </p:nvSpPr>
         <p:spPr>
           <a:xfrm>
-            <a:off x="1897379" y="1901952"/>
-            <a:ext cx="1440180" cy="566928"/>
+            <a:off x="1897379" y="1828800"/>
+            <a:ext cx="1440180" cy="512064"/>
           </a:xfrm>
           <a:prstGeom prst="rect">
             <a:avLst/>
@@ -18384,12 +18384,12 @@
         </p:nvSpPr>
         <p:spPr>
           <a:xfrm>
-            <a:off x="3474720" y="1554480"/>
-            <a:ext cx="1440180" cy="950976"/>
+            <a:off x="3474720" y="1517904"/>
+            <a:ext cx="1440180" cy="841248"/>
           </a:xfrm>
           <a:prstGeom prst="roundRect">
             <a:avLst>
-              <a:gd name="adj" fmla="val 9615"/>
+              <a:gd name="adj" fmla="val 10869"/>
             </a:avLst>
           </a:prstGeom>
           <a:solidFill>
@@ -18422,8 +18422,8 @@
         </p:blipFill>
         <p:spPr>
           <a:xfrm>
-            <a:off x="4066794" y="1627632"/>
-            <a:ext cx="256032" cy="256032"/>
+            <a:off x="4075937" y="1572768"/>
+            <a:ext cx="237744" cy="237744"/>
           </a:xfrm>
           <a:prstGeom prst="rect">
             <a:avLst/>
@@ -18438,8 +18438,8 @@
         </p:nvSpPr>
         <p:spPr>
           <a:xfrm>
-            <a:off x="3474720" y="1901952"/>
-            <a:ext cx="1440180" cy="566928"/>
+            <a:off x="3474720" y="1828800"/>
+            <a:ext cx="1440180" cy="512064"/>
           </a:xfrm>
           <a:prstGeom prst="rect">
             <a:avLst/>
@@ -18515,12 +18515,12 @@
         </p:nvSpPr>
         <p:spPr>
           <a:xfrm>
-            <a:off x="5052059" y="1554480"/>
-            <a:ext cx="1440180" cy="950976"/>
+            <a:off x="5052059" y="1517904"/>
+            <a:ext cx="1440180" cy="841248"/>
           </a:xfrm>
           <a:prstGeom prst="roundRect">
             <a:avLst>
-              <a:gd name="adj" fmla="val 9615"/>
+              <a:gd name="adj" fmla="val 10869"/>
             </a:avLst>
           </a:prstGeom>
           <a:solidFill>
@@ -18553,8 +18553,8 @@
         </p:blipFill>
         <p:spPr>
           <a:xfrm>
-            <a:off x="5644133" y="1627632"/>
-            <a:ext cx="256032" cy="256032"/>
+            <a:off x="5653277" y="1572768"/>
+            <a:ext cx="237744" cy="237744"/>
           </a:xfrm>
           <a:prstGeom prst="rect">
             <a:avLst/>
@@ -18569,8 +18569,8 @@
         </p:nvSpPr>
         <p:spPr>
           <a:xfrm>
-            <a:off x="5052059" y="1901952"/>
-            <a:ext cx="1440180" cy="566928"/>
+            <a:off x="5052059" y="1828800"/>
+            <a:ext cx="1440180" cy="512064"/>
           </a:xfrm>
           <a:prstGeom prst="rect">
             <a:avLst/>
@@ -18646,7 +18646,7 @@
         </p:nvSpPr>
         <p:spPr>
           <a:xfrm>
-            <a:off x="320040" y="2560320"/>
+            <a:off x="320040" y="2395728"/>
             <a:ext cx="6172200" cy="237744"/>
           </a:xfrm>
           <a:prstGeom prst="rect">
@@ -18687,7 +18687,7 @@
         </p:nvSpPr>
         <p:spPr>
           <a:xfrm>
-            <a:off x="320040" y="2871216"/>
+            <a:off x="320040" y="2706624"/>
             <a:ext cx="274320" cy="274320"/>
           </a:xfrm>
           <a:prstGeom prst="roundRect">
@@ -18725,7 +18725,7 @@
         </p:blipFill>
         <p:spPr>
           <a:xfrm>
-            <a:off x="374904" y="2926080"/>
+            <a:off x="374904" y="2761488"/>
             <a:ext cx="164592" cy="164592"/>
           </a:xfrm>
           <a:prstGeom prst="rect">
@@ -18741,7 +18741,7 @@
         </p:nvSpPr>
         <p:spPr>
           <a:xfrm>
-            <a:off x="667512" y="2852928"/>
+            <a:off x="667512" y="2688336"/>
             <a:ext cx="5824728" cy="310896"/>
           </a:xfrm>
           <a:prstGeom prst="rect">
@@ -18793,12 +18793,12 @@
         </p:nvSpPr>
         <p:spPr>
           <a:xfrm>
-            <a:off x="320040" y="3236976"/>
-            <a:ext cx="3017520" cy="1060704"/>
+            <a:off x="320040" y="3035808"/>
+            <a:ext cx="3017520" cy="914400"/>
           </a:xfrm>
           <a:prstGeom prst="roundRect">
             <a:avLst>
-              <a:gd name="adj" fmla="val 8620"/>
+              <a:gd name="adj" fmla="val 10000"/>
             </a:avLst>
           </a:prstGeom>
           <a:solidFill>
@@ -18825,8 +18825,8 @@
         </p:nvSpPr>
         <p:spPr>
           <a:xfrm>
-            <a:off x="448056" y="3346704"/>
-            <a:ext cx="347472" cy="347472"/>
+            <a:off x="448056" y="3108960"/>
+            <a:ext cx="292608" cy="292608"/>
           </a:xfrm>
           <a:prstGeom prst="roundRect">
             <a:avLst>
@@ -18863,8 +18863,8 @@
         </p:blipFill>
         <p:spPr>
           <a:xfrm>
-            <a:off x="517550" y="3416198"/>
-            <a:ext cx="208483" cy="208483"/>
+            <a:off x="506577" y="3167481"/>
+            <a:ext cx="175564" cy="175564"/>
           </a:xfrm>
           <a:prstGeom prst="rect">
             <a:avLst/>
@@ -18879,8 +18879,8 @@
         </p:nvSpPr>
         <p:spPr>
           <a:xfrm>
-            <a:off x="886968" y="3346704"/>
-            <a:ext cx="2340863" cy="347472"/>
+            <a:off x="832104" y="3108960"/>
+            <a:ext cx="2395727" cy="292608"/>
           </a:xfrm>
           <a:prstGeom prst="rect">
             <a:avLst/>
@@ -18920,8 +18920,8 @@
         </p:nvSpPr>
         <p:spPr>
           <a:xfrm>
-            <a:off x="448056" y="3749039"/>
-            <a:ext cx="2761487" cy="512063"/>
+            <a:off x="448056" y="3438144"/>
+            <a:ext cx="2761487" cy="457200"/>
           </a:xfrm>
           <a:prstGeom prst="rect">
             <a:avLst/>
@@ -18961,12 +18961,12 @@
         </p:nvSpPr>
         <p:spPr>
           <a:xfrm>
-            <a:off x="3474720" y="3236976"/>
-            <a:ext cx="3017520" cy="1060704"/>
+            <a:off x="3474720" y="3035808"/>
+            <a:ext cx="3017520" cy="914400"/>
           </a:xfrm>
           <a:prstGeom prst="roundRect">
             <a:avLst>
-              <a:gd name="adj" fmla="val 8620"/>
+              <a:gd name="adj" fmla="val 10000"/>
             </a:avLst>
           </a:prstGeom>
           <a:solidFill>
@@ -18993,8 +18993,8 @@
         </p:nvSpPr>
         <p:spPr>
           <a:xfrm>
-            <a:off x="3602736" y="3346704"/>
-            <a:ext cx="347472" cy="347472"/>
+            <a:off x="3602736" y="3108960"/>
+            <a:ext cx="292608" cy="292608"/>
           </a:xfrm>
           <a:prstGeom prst="roundRect">
             <a:avLst>
@@ -19031,8 +19031,8 @@
         </p:blipFill>
         <p:spPr>
           <a:xfrm>
-            <a:off x="3672230" y="3416198"/>
-            <a:ext cx="208483" cy="208483"/>
+            <a:off x="3661257" y="3167481"/>
+            <a:ext cx="175564" cy="175564"/>
           </a:xfrm>
           <a:prstGeom prst="rect">
             <a:avLst/>
@@ -19047,8 +19047,8 @@
         </p:nvSpPr>
         <p:spPr>
           <a:xfrm>
-            <a:off x="4041648" y="3346704"/>
-            <a:ext cx="2340863" cy="347472"/>
+            <a:off x="3986783" y="3108960"/>
+            <a:ext cx="2395727" cy="292608"/>
           </a:xfrm>
           <a:prstGeom prst="rect">
             <a:avLst/>
@@ -19088,8 +19088,8 @@
         </p:nvSpPr>
         <p:spPr>
           <a:xfrm>
-            <a:off x="3602736" y="3749039"/>
-            <a:ext cx="2761487" cy="512063"/>
+            <a:off x="3602736" y="3438144"/>
+            <a:ext cx="2761487" cy="457200"/>
           </a:xfrm>
           <a:prstGeom prst="rect">
             <a:avLst/>
@@ -19129,12 +19129,12 @@
         </p:nvSpPr>
         <p:spPr>
           <a:xfrm>
-            <a:off x="320040" y="4407408"/>
-            <a:ext cx="3017520" cy="1060704"/>
+            <a:off x="320040" y="4041648"/>
+            <a:ext cx="3017520" cy="914400"/>
           </a:xfrm>
           <a:prstGeom prst="roundRect">
             <a:avLst>
-              <a:gd name="adj" fmla="val 8620"/>
+              <a:gd name="adj" fmla="val 10000"/>
             </a:avLst>
           </a:prstGeom>
           <a:solidFill>
@@ -19161,8 +19161,8 @@
         </p:nvSpPr>
         <p:spPr>
           <a:xfrm>
-            <a:off x="448056" y="4517136"/>
-            <a:ext cx="347472" cy="347472"/>
+            <a:off x="448056" y="4114800"/>
+            <a:ext cx="292608" cy="292608"/>
           </a:xfrm>
           <a:prstGeom prst="roundRect">
             <a:avLst>
@@ -19199,8 +19199,8 @@
         </p:blipFill>
         <p:spPr>
           <a:xfrm>
-            <a:off x="517550" y="4586630"/>
-            <a:ext cx="208483" cy="208483"/>
+            <a:off x="506577" y="4173321"/>
+            <a:ext cx="175564" cy="175564"/>
           </a:xfrm>
           <a:prstGeom prst="rect">
             <a:avLst/>
@@ -19215,8 +19215,8 @@
         </p:nvSpPr>
         <p:spPr>
           <a:xfrm>
-            <a:off x="886968" y="4517136"/>
-            <a:ext cx="2340863" cy="347472"/>
+            <a:off x="832104" y="4114800"/>
+            <a:ext cx="2395727" cy="292608"/>
           </a:xfrm>
           <a:prstGeom prst="rect">
             <a:avLst/>
@@ -19256,8 +19256,8 @@
         </p:nvSpPr>
         <p:spPr>
           <a:xfrm>
-            <a:off x="448056" y="4919472"/>
-            <a:ext cx="2761487" cy="512063"/>
+            <a:off x="448056" y="4443984"/>
+            <a:ext cx="2761487" cy="457200"/>
           </a:xfrm>
           <a:prstGeom prst="rect">
             <a:avLst/>
@@ -19297,12 +19297,12 @@
         </p:nvSpPr>
         <p:spPr>
           <a:xfrm>
-            <a:off x="3474720" y="4407408"/>
-            <a:ext cx="3017520" cy="1060704"/>
+            <a:off x="3474720" y="4041648"/>
+            <a:ext cx="3017520" cy="914400"/>
           </a:xfrm>
           <a:prstGeom prst="roundRect">
             <a:avLst>
-              <a:gd name="adj" fmla="val 8620"/>
+              <a:gd name="adj" fmla="val 10000"/>
             </a:avLst>
           </a:prstGeom>
           <a:solidFill>
@@ -19329,8 +19329,8 @@
         </p:nvSpPr>
         <p:spPr>
           <a:xfrm>
-            <a:off x="3602736" y="4517136"/>
-            <a:ext cx="347472" cy="347472"/>
+            <a:off x="3602736" y="4114800"/>
+            <a:ext cx="292608" cy="292608"/>
           </a:xfrm>
           <a:prstGeom prst="roundRect">
             <a:avLst>
@@ -19367,8 +19367,8 @@
         </p:blipFill>
         <p:spPr>
           <a:xfrm>
-            <a:off x="3672230" y="4586630"/>
-            <a:ext cx="208483" cy="208483"/>
+            <a:off x="3661257" y="4173321"/>
+            <a:ext cx="175564" cy="175564"/>
           </a:xfrm>
           <a:prstGeom prst="rect">
             <a:avLst/>
@@ -19383,8 +19383,8 @@
         </p:nvSpPr>
         <p:spPr>
           <a:xfrm>
-            <a:off x="4041648" y="4517136"/>
-            <a:ext cx="2340863" cy="347472"/>
+            <a:off x="3986783" y="4114800"/>
+            <a:ext cx="2395727" cy="292608"/>
           </a:xfrm>
           <a:prstGeom prst="rect">
             <a:avLst/>
@@ -19424,8 +19424,8 @@
         </p:nvSpPr>
         <p:spPr>
           <a:xfrm>
-            <a:off x="3602736" y="4919472"/>
-            <a:ext cx="2761487" cy="512063"/>
+            <a:off x="3602736" y="4443984"/>
+            <a:ext cx="2761487" cy="457200"/>
           </a:xfrm>
           <a:prstGeom prst="rect">
             <a:avLst/>
@@ -19565,7 +19565,7 @@
       </p:sp>
       <p:pic>
         <p:nvPicPr>
-          <p:cNvPr id="17452" name="Picture 17451" descr="fuel_crop_215790.png"/>
+          <p:cNvPr id="17452" name="Picture 17451" descr="fuel_crop_523447.png"/>
           <p:cNvPicPr>
             <a:picLocks noChangeAspect="1"/>
           </p:cNvPicPr>
@@ -19579,8 +19579,8 @@
         </p:blipFill>
         <p:spPr>
           <a:xfrm>
-            <a:off x="6766560" y="1554480"/>
-            <a:ext cx="2505456" cy="2557653"/>
+            <a:off x="9737445" y="1517904"/>
+            <a:ext cx="2150126" cy="2267712"/>
           </a:xfrm>
           <a:prstGeom prst="rect">
             <a:avLst/>
@@ -19594,7 +19594,7 @@
       </p:pic>
       <p:pic>
         <p:nvPicPr>
-          <p:cNvPr id="17453" name="Picture 17452" descr="fuel_crop_607028.png"/>
+          <p:cNvPr id="17453" name="Picture 17452" descr="fuel_crop_451553.png"/>
           <p:cNvPicPr>
             <a:picLocks noChangeAspect="1"/>
           </p:cNvPicPr>
@@ -19608,8 +19608,8 @@
         </p:blipFill>
         <p:spPr>
           <a:xfrm>
-            <a:off x="9381744" y="1554480"/>
-            <a:ext cx="2505456" cy="2664493"/>
+            <a:off x="6766560" y="1517904"/>
+            <a:ext cx="2861157" cy="2267712"/>
           </a:xfrm>
           <a:prstGeom prst="rect">
             <a:avLst/>
@@ -19629,8 +19629,8 @@
         </p:nvSpPr>
         <p:spPr>
           <a:xfrm>
-            <a:off x="6766560" y="4273837"/>
-            <a:ext cx="5120640" cy="499330"/>
+            <a:off x="6766560" y="3822191"/>
+            <a:ext cx="5120640" cy="530352"/>
           </a:xfrm>
           <a:prstGeom prst="rect">
             <a:avLst/>
@@ -19681,12 +19681,12 @@
         </p:nvSpPr>
         <p:spPr>
           <a:xfrm>
-            <a:off x="6766560" y="4828032"/>
-            <a:ext cx="5120640" cy="640080"/>
+            <a:off x="6766560" y="4389120"/>
+            <a:ext cx="5120640" cy="566928"/>
           </a:xfrm>
           <a:prstGeom prst="roundRect">
             <a:avLst>
-              <a:gd name="adj" fmla="val 14285"/>
+              <a:gd name="adj" fmla="val 16129"/>
             </a:avLst>
           </a:prstGeom>
           <a:solidFill>
@@ -19711,8 +19711,8 @@
         </p:nvSpPr>
         <p:spPr>
           <a:xfrm>
-            <a:off x="6912864" y="4965192"/>
-            <a:ext cx="365760" cy="365760"/>
+            <a:off x="6912864" y="4498848"/>
+            <a:ext cx="347472" cy="347472"/>
           </a:xfrm>
           <a:prstGeom prst="roundRect">
             <a:avLst>
@@ -19749,8 +19749,8 @@
         </p:blipFill>
         <p:spPr>
           <a:xfrm>
-            <a:off x="6986016" y="5038344"/>
-            <a:ext cx="219456" cy="219456"/>
+            <a:off x="6982358" y="4568342"/>
+            <a:ext cx="208483" cy="208483"/>
           </a:xfrm>
           <a:prstGeom prst="rect">
             <a:avLst/>
@@ -19765,8 +19765,8 @@
         </p:nvSpPr>
         <p:spPr>
           <a:xfrm>
-            <a:off x="7388352" y="4828032"/>
-            <a:ext cx="4389120" cy="640080"/>
+            <a:off x="7370064" y="4389120"/>
+            <a:ext cx="4407407" cy="566928"/>
           </a:xfrm>
           <a:prstGeom prst="rect">
             <a:avLst/>
@@ -19842,12 +19842,12 @@
         </p:nvSpPr>
         <p:spPr>
           <a:xfrm>
-            <a:off x="320040" y="5577840"/>
-            <a:ext cx="3733799" cy="658368"/>
+            <a:off x="320040" y="5065776"/>
+            <a:ext cx="3733799" cy="548640"/>
           </a:xfrm>
           <a:prstGeom prst="roundRect">
             <a:avLst>
-              <a:gd name="adj" fmla="val 13888"/>
+              <a:gd name="adj" fmla="val 16666"/>
             </a:avLst>
           </a:prstGeom>
           <a:solidFill>
@@ -19874,8 +19874,8 @@
         </p:nvSpPr>
         <p:spPr>
           <a:xfrm>
-            <a:off x="466344" y="5715000"/>
-            <a:ext cx="384048" cy="384048"/>
+            <a:off x="448056" y="5166360"/>
+            <a:ext cx="347472" cy="347472"/>
           </a:xfrm>
           <a:prstGeom prst="roundRect">
             <a:avLst>
@@ -19912,8 +19912,8 @@
         </p:blipFill>
         <p:spPr>
           <a:xfrm>
-            <a:off x="543153" y="5791809"/>
-            <a:ext cx="230428" cy="230428"/>
+            <a:off x="517550" y="5235854"/>
+            <a:ext cx="208483" cy="208483"/>
           </a:xfrm>
           <a:prstGeom prst="rect">
             <a:avLst/>
@@ -19928,8 +19928,8 @@
         </p:nvSpPr>
         <p:spPr>
           <a:xfrm>
-            <a:off x="978407" y="5650992"/>
-            <a:ext cx="2947416" cy="256032"/>
+            <a:off x="923544" y="5120640"/>
+            <a:ext cx="3002280" cy="228600"/>
           </a:xfrm>
           <a:prstGeom prst="rect">
             <a:avLst/>
@@ -19948,7 +19948,7 @@
               </a:lnSpc>
             </a:pPr>
             <a:r>
-              <a:rPr sz="1150" b="1" i="0">
+              <a:rPr sz="1100" b="1" i="0">
                 <a:solidFill>
                   <a:srgbClr val="0E869A"/>
                 </a:solidFill>
@@ -19969,8 +19969,8 @@
         </p:nvSpPr>
         <p:spPr>
           <a:xfrm>
-            <a:off x="978407" y="5925312"/>
-            <a:ext cx="2947416" cy="237744"/>
+            <a:off x="923544" y="5349240"/>
+            <a:ext cx="3002280" cy="210312"/>
           </a:xfrm>
           <a:prstGeom prst="rect">
             <a:avLst/>
@@ -20010,12 +20010,12 @@
         </p:nvSpPr>
         <p:spPr>
           <a:xfrm>
-            <a:off x="4236720" y="5577840"/>
-            <a:ext cx="3733799" cy="658368"/>
+            <a:off x="4236720" y="5065776"/>
+            <a:ext cx="3733799" cy="548640"/>
           </a:xfrm>
           <a:prstGeom prst="roundRect">
             <a:avLst>
-              <a:gd name="adj" fmla="val 13888"/>
+              <a:gd name="adj" fmla="val 16666"/>
             </a:avLst>
           </a:prstGeom>
           <a:solidFill>
@@ -20042,8 +20042,8 @@
         </p:nvSpPr>
         <p:spPr>
           <a:xfrm>
-            <a:off x="4383024" y="5715000"/>
-            <a:ext cx="384048" cy="384048"/>
+            <a:off x="4364735" y="5166360"/>
+            <a:ext cx="347472" cy="347472"/>
           </a:xfrm>
           <a:prstGeom prst="roundRect">
             <a:avLst>
@@ -20080,8 +20080,8 @@
         </p:blipFill>
         <p:spPr>
           <a:xfrm>
-            <a:off x="4459833" y="5791809"/>
-            <a:ext cx="230428" cy="230428"/>
+            <a:off x="4434230" y="5235854"/>
+            <a:ext cx="208483" cy="208483"/>
           </a:xfrm>
           <a:prstGeom prst="rect">
             <a:avLst/>
@@ -20096,8 +20096,8 @@
         </p:nvSpPr>
         <p:spPr>
           <a:xfrm>
-            <a:off x="4895087" y="5650992"/>
-            <a:ext cx="2947416" cy="256032"/>
+            <a:off x="4840224" y="5120640"/>
+            <a:ext cx="3002280" cy="228600"/>
           </a:xfrm>
           <a:prstGeom prst="rect">
             <a:avLst/>
@@ -20116,7 +20116,7 @@
               </a:lnSpc>
             </a:pPr>
             <a:r>
-              <a:rPr sz="1150" b="1" i="0">
+              <a:rPr sz="1100" b="1" i="0">
                 <a:solidFill>
                   <a:srgbClr val="0E869A"/>
                 </a:solidFill>
@@ -20137,8 +20137,8 @@
         </p:nvSpPr>
         <p:spPr>
           <a:xfrm>
-            <a:off x="4895087" y="5925312"/>
-            <a:ext cx="2947416" cy="237744"/>
+            <a:off x="4840224" y="5349240"/>
+            <a:ext cx="3002280" cy="210312"/>
           </a:xfrm>
           <a:prstGeom prst="rect">
             <a:avLst/>
@@ -20178,12 +20178,12 @@
         </p:nvSpPr>
         <p:spPr>
           <a:xfrm>
-            <a:off x="8153399" y="5577840"/>
-            <a:ext cx="3733799" cy="658368"/>
+            <a:off x="8153399" y="5065776"/>
+            <a:ext cx="3733799" cy="548640"/>
           </a:xfrm>
           <a:prstGeom prst="roundRect">
             <a:avLst>
-              <a:gd name="adj" fmla="val 13888"/>
+              <a:gd name="adj" fmla="val 16666"/>
             </a:avLst>
           </a:prstGeom>
           <a:solidFill>
@@ -20210,8 +20210,8 @@
         </p:nvSpPr>
         <p:spPr>
           <a:xfrm>
-            <a:off x="8299704" y="5715000"/>
-            <a:ext cx="384048" cy="384048"/>
+            <a:off x="8281416" y="5166360"/>
+            <a:ext cx="347472" cy="347472"/>
           </a:xfrm>
           <a:prstGeom prst="roundRect">
             <a:avLst>
@@ -20248,8 +20248,8 @@
         </p:blipFill>
         <p:spPr>
           <a:xfrm>
-            <a:off x="8376513" y="5791809"/>
-            <a:ext cx="230428" cy="230428"/>
+            <a:off x="8350910" y="5235854"/>
+            <a:ext cx="208483" cy="208483"/>
           </a:xfrm>
           <a:prstGeom prst="rect">
             <a:avLst/>
@@ -20264,8 +20264,8 @@
         </p:nvSpPr>
         <p:spPr>
           <a:xfrm>
-            <a:off x="8811768" y="5650992"/>
-            <a:ext cx="2947416" cy="256032"/>
+            <a:off x="8756904" y="5120640"/>
+            <a:ext cx="3002280" cy="228600"/>
           </a:xfrm>
           <a:prstGeom prst="rect">
             <a:avLst/>
@@ -20284,7 +20284,7 @@
               </a:lnSpc>
             </a:pPr>
             <a:r>
-              <a:rPr sz="1150" b="1" i="0">
+              <a:rPr sz="1100" b="1" i="0">
                 <a:solidFill>
                   <a:srgbClr val="0E869A"/>
                 </a:solidFill>
@@ -20305,8 +20305,8 @@
         </p:nvSpPr>
         <p:spPr>
           <a:xfrm>
-            <a:off x="8811768" y="5925312"/>
-            <a:ext cx="2947416" cy="237744"/>
+            <a:off x="8756904" y="5349240"/>
+            <a:ext cx="3002280" cy="210312"/>
           </a:xfrm>
           <a:prstGeom prst="rect">
             <a:avLst/>
@@ -20334,6 +20334,510 @@
                 <a:cs typeface="Arial"/>
               </a:rPr>
               <a:t>Generate PDF / CSV report for the selected point</a:t>
+            </a:r>
+          </a:p>
+        </p:txBody>
+      </p:sp>
+      <p:sp>
+        <p:nvSpPr>
+          <p:cNvPr id="17474" name="Rounded Rectangle 17473"/>
+          <p:cNvSpPr/>
+          <p:nvPr/>
+        </p:nvSpPr>
+        <p:spPr>
+          <a:xfrm>
+            <a:off x="320040" y="5705855"/>
+            <a:ext cx="3733799" cy="548640"/>
+          </a:xfrm>
+          <a:prstGeom prst="roundRect">
+            <a:avLst>
+              <a:gd name="adj" fmla="val 16666"/>
+            </a:avLst>
+          </a:prstGeom>
+          <a:solidFill>
+            <a:srgbClr val="FDF3E6"/>
+          </a:solidFill>
+          <a:ln w="15875">
+            <a:solidFill>
+              <a:srgbClr val="0B2F4E"/>
+            </a:solidFill>
+          </a:ln>
+          <a:effectLst/>
+        </p:spPr>
+        <p:txBody>
+          <a:bodyPr rtlCol="0" anchor="ctr"/>
+          <a:lstStyle/>
+          <a:p/>
+        </p:txBody>
+      </p:sp>
+      <p:sp>
+        <p:nvSpPr>
+          <p:cNvPr id="17475" name="Rounded Rectangle 17474"/>
+          <p:cNvSpPr/>
+          <p:nvPr/>
+        </p:nvSpPr>
+        <p:spPr>
+          <a:xfrm>
+            <a:off x="448056" y="5806440"/>
+            <a:ext cx="347472" cy="347472"/>
+          </a:xfrm>
+          <a:prstGeom prst="roundRect">
+            <a:avLst>
+              <a:gd name="adj" fmla="val 22000"/>
+            </a:avLst>
+          </a:prstGeom>
+          <a:solidFill>
+            <a:srgbClr val="0070C0"/>
+          </a:solidFill>
+          <a:ln>
+            <a:noFill/>
+          </a:ln>
+          <a:effectLst/>
+        </p:spPr>
+        <p:txBody>
+          <a:bodyPr rtlCol="0" anchor="ctr"/>
+          <a:lstStyle/>
+          <a:p/>
+        </p:txBody>
+      </p:sp>
+      <p:pic>
+        <p:nvPicPr>
+          <p:cNvPr id="17476" name="Picture 17475" descr="video-FFFFFF.png"/>
+          <p:cNvPicPr>
+            <a:picLocks noChangeAspect="1"/>
+          </p:cNvPicPr>
+          <p:nvPr/>
+        </p:nvPicPr>
+        <p:blipFill>
+          <a:blip r:embed="rId23"/>
+          <a:stretch>
+            <a:fillRect/>
+          </a:stretch>
+        </p:blipFill>
+        <p:spPr>
+          <a:xfrm>
+            <a:off x="517550" y="5875934"/>
+            <a:ext cx="208483" cy="208483"/>
+          </a:xfrm>
+          <a:prstGeom prst="rect">
+            <a:avLst/>
+          </a:prstGeom>
+        </p:spPr>
+      </p:pic>
+      <p:sp>
+        <p:nvSpPr>
+          <p:cNvPr id="17477" name="TextBox 17476"/>
+          <p:cNvSpPr txBox="1"/>
+          <p:nvPr/>
+        </p:nvSpPr>
+        <p:spPr>
+          <a:xfrm>
+            <a:off x="923544" y="5760719"/>
+            <a:ext cx="3002280" cy="228600"/>
+          </a:xfrm>
+          <a:prstGeom prst="rect">
+            <a:avLst/>
+          </a:prstGeom>
+          <a:noFill/>
+        </p:spPr>
+        <p:txBody>
+          <a:bodyPr wrap="square" anchor="ctr" lIns="9144" rIns="9144" tIns="9144" bIns="9144">
+            <a:spAutoFit/>
+          </a:bodyPr>
+          <a:lstStyle/>
+          <a:p>
+            <a:pPr algn="l">
+              <a:lnSpc>
+                <a:spcPct val="100000"/>
+              </a:lnSpc>
+            </a:pPr>
+            <a:r>
+              <a:rPr sz="1100" b="1" i="0">
+                <a:solidFill>
+                  <a:srgbClr val="0070C0"/>
+                </a:solidFill>
+                <a:latin typeface="Arial"/>
+                <a:ea typeface="Arial"/>
+                <a:cs typeface="Arial"/>
+              </a:rPr>
+              <a:t>DEMO VIDEO</a:t>
+            </a:r>
+          </a:p>
+        </p:txBody>
+      </p:sp>
+      <p:sp>
+        <p:nvSpPr>
+          <p:cNvPr id="17478" name="TextBox 17477"/>
+          <p:cNvSpPr txBox="1"/>
+          <p:nvPr/>
+        </p:nvSpPr>
+        <p:spPr>
+          <a:xfrm>
+            <a:off x="923544" y="5989319"/>
+            <a:ext cx="3002280" cy="210312"/>
+          </a:xfrm>
+          <a:prstGeom prst="rect">
+            <a:avLst/>
+          </a:prstGeom>
+          <a:noFill/>
+        </p:spPr>
+        <p:txBody>
+          <a:bodyPr wrap="square" anchor="ctr" lIns="9144" rIns="9144" tIns="9144" bIns="9144">
+            <a:spAutoFit/>
+          </a:bodyPr>
+          <a:lstStyle/>
+          <a:p>
+            <a:pPr algn="l">
+              <a:lnSpc>
+                <a:spcPct val="100000"/>
+              </a:lnSpc>
+            </a:pPr>
+            <a:r>
+              <a:rPr sz="1000" b="0" i="0">
+                <a:solidFill>
+                  <a:srgbClr val="1B2330"/>
+                </a:solidFill>
+                <a:latin typeface="Arial"/>
+                <a:ea typeface="Arial"/>
+                <a:cs typeface="Arial"/>
+              </a:rPr>
+              <a:t>Watch the complete OceanSight demonstration</a:t>
+            </a:r>
+          </a:p>
+        </p:txBody>
+      </p:sp>
+      <p:sp>
+        <p:nvSpPr>
+          <p:cNvPr id="17479" name="Rounded Rectangle 17478"/>
+          <p:cNvSpPr/>
+          <p:nvPr/>
+        </p:nvSpPr>
+        <p:spPr>
+          <a:xfrm>
+            <a:off x="4236720" y="5705855"/>
+            <a:ext cx="3733799" cy="548640"/>
+          </a:xfrm>
+          <a:prstGeom prst="roundRect">
+            <a:avLst>
+              <a:gd name="adj" fmla="val 16666"/>
+            </a:avLst>
+          </a:prstGeom>
+          <a:solidFill>
+            <a:srgbClr val="FDF3E6"/>
+          </a:solidFill>
+          <a:ln w="15875">
+            <a:solidFill>
+              <a:srgbClr val="0B2F4E"/>
+            </a:solidFill>
+          </a:ln>
+          <a:effectLst/>
+        </p:spPr>
+        <p:txBody>
+          <a:bodyPr rtlCol="0" anchor="ctr"/>
+          <a:lstStyle/>
+          <a:p/>
+        </p:txBody>
+      </p:sp>
+      <p:sp>
+        <p:nvSpPr>
+          <p:cNvPr id="17480" name="Rounded Rectangle 17479"/>
+          <p:cNvSpPr/>
+          <p:nvPr/>
+        </p:nvSpPr>
+        <p:spPr>
+          <a:xfrm>
+            <a:off x="4364735" y="5806440"/>
+            <a:ext cx="347472" cy="347472"/>
+          </a:xfrm>
+          <a:prstGeom prst="roundRect">
+            <a:avLst>
+              <a:gd name="adj" fmla="val 22000"/>
+            </a:avLst>
+          </a:prstGeom>
+          <a:solidFill>
+            <a:srgbClr val="0070C0"/>
+          </a:solidFill>
+          <a:ln>
+            <a:noFill/>
+          </a:ln>
+          <a:effectLst/>
+        </p:spPr>
+        <p:txBody>
+          <a:bodyPr rtlCol="0" anchor="ctr"/>
+          <a:lstStyle/>
+          <a:p/>
+        </p:txBody>
+      </p:sp>
+      <p:pic>
+        <p:nvPicPr>
+          <p:cNvPr id="17481" name="Picture 17480" descr="folder-open-FFFFFF.png"/>
+          <p:cNvPicPr>
+            <a:picLocks noChangeAspect="1"/>
+          </p:cNvPicPr>
+          <p:nvPr/>
+        </p:nvPicPr>
+        <p:blipFill>
+          <a:blip r:embed="rId24"/>
+          <a:stretch>
+            <a:fillRect/>
+          </a:stretch>
+        </p:blipFill>
+        <p:spPr>
+          <a:xfrm>
+            <a:off x="4434230" y="5875934"/>
+            <a:ext cx="208483" cy="208483"/>
+          </a:xfrm>
+          <a:prstGeom prst="rect">
+            <a:avLst/>
+          </a:prstGeom>
+        </p:spPr>
+      </p:pic>
+      <p:sp>
+        <p:nvSpPr>
+          <p:cNvPr id="17482" name="TextBox 17481"/>
+          <p:cNvSpPr txBox="1"/>
+          <p:nvPr/>
+        </p:nvSpPr>
+        <p:spPr>
+          <a:xfrm>
+            <a:off x="4840224" y="5760719"/>
+            <a:ext cx="3002280" cy="228600"/>
+          </a:xfrm>
+          <a:prstGeom prst="rect">
+            <a:avLst/>
+          </a:prstGeom>
+          <a:noFill/>
+        </p:spPr>
+        <p:txBody>
+          <a:bodyPr wrap="square" anchor="ctr" lIns="9144" rIns="9144" tIns="9144" bIns="9144">
+            <a:spAutoFit/>
+          </a:bodyPr>
+          <a:lstStyle/>
+          <a:p>
+            <a:pPr algn="l">
+              <a:lnSpc>
+                <a:spcPct val="100000"/>
+              </a:lnSpc>
+            </a:pPr>
+            <a:r>
+              <a:rPr sz="1100" b="1" i="0">
+                <a:solidFill>
+                  <a:srgbClr val="0070C0"/>
+                </a:solidFill>
+                <a:latin typeface="Arial"/>
+                <a:ea typeface="Arial"/>
+                <a:cs typeface="Arial"/>
+              </a:rPr>
+              <a:t>VIEW DEMO VIDEO (DRIVE)</a:t>
+            </a:r>
+          </a:p>
+        </p:txBody>
+      </p:sp>
+      <p:sp>
+        <p:nvSpPr>
+          <p:cNvPr id="17483" name="TextBox 17482"/>
+          <p:cNvSpPr txBox="1"/>
+          <p:nvPr/>
+        </p:nvSpPr>
+        <p:spPr>
+          <a:xfrm>
+            <a:off x="4840224" y="5989319"/>
+            <a:ext cx="3002280" cy="210312"/>
+          </a:xfrm>
+          <a:prstGeom prst="rect">
+            <a:avLst/>
+          </a:prstGeom>
+          <a:noFill/>
+        </p:spPr>
+        <p:txBody>
+          <a:bodyPr wrap="square" anchor="ctr" lIns="9144" rIns="9144" tIns="9144" bIns="9144">
+            <a:spAutoFit/>
+          </a:bodyPr>
+          <a:lstStyle/>
+          <a:p>
+            <a:pPr algn="l">
+              <a:lnSpc>
+                <a:spcPct val="100000"/>
+              </a:lnSpc>
+            </a:pPr>
+            <a:r>
+              <a:rPr sz="1000" b="0" i="0">
+                <a:solidFill>
+                  <a:srgbClr val="1B2330"/>
+                </a:solidFill>
+                <a:latin typeface="Arial"/>
+                <a:ea typeface="Arial"/>
+                <a:cs typeface="Arial"/>
+              </a:rPr>
+              <a:t>Access the OceanSight demonstration video</a:t>
+            </a:r>
+          </a:p>
+        </p:txBody>
+      </p:sp>
+      <p:sp>
+        <p:nvSpPr>
+          <p:cNvPr id="17484" name="Rounded Rectangle 17483"/>
+          <p:cNvSpPr/>
+          <p:nvPr/>
+        </p:nvSpPr>
+        <p:spPr>
+          <a:xfrm>
+            <a:off x="8153399" y="5705855"/>
+            <a:ext cx="3733799" cy="548640"/>
+          </a:xfrm>
+          <a:prstGeom prst="roundRect">
+            <a:avLst>
+              <a:gd name="adj" fmla="val 16666"/>
+            </a:avLst>
+          </a:prstGeom>
+          <a:solidFill>
+            <a:srgbClr val="FDF3E6"/>
+          </a:solidFill>
+          <a:ln w="15875">
+            <a:solidFill>
+              <a:srgbClr val="0B2F4E"/>
+            </a:solidFill>
+          </a:ln>
+          <a:effectLst/>
+        </p:spPr>
+        <p:txBody>
+          <a:bodyPr rtlCol="0" anchor="ctr"/>
+          <a:lstStyle/>
+          <a:p/>
+        </p:txBody>
+      </p:sp>
+      <p:sp>
+        <p:nvSpPr>
+          <p:cNvPr id="17485" name="Rounded Rectangle 17484"/>
+          <p:cNvSpPr/>
+          <p:nvPr/>
+        </p:nvSpPr>
+        <p:spPr>
+          <a:xfrm>
+            <a:off x="8281416" y="5806440"/>
+            <a:ext cx="347472" cy="347472"/>
+          </a:xfrm>
+          <a:prstGeom prst="roundRect">
+            <a:avLst>
+              <a:gd name="adj" fmla="val 22000"/>
+            </a:avLst>
+          </a:prstGeom>
+          <a:solidFill>
+            <a:srgbClr val="0070C0"/>
+          </a:solidFill>
+          <a:ln>
+            <a:noFill/>
+          </a:ln>
+          <a:effectLst/>
+        </p:spPr>
+        <p:txBody>
+          <a:bodyPr rtlCol="0" anchor="ctr"/>
+          <a:lstStyle/>
+          <a:p/>
+        </p:txBody>
+      </p:sp>
+      <p:pic>
+        <p:nvPicPr>
+          <p:cNvPr id="17486" name="Picture 17485" descr="globe-FFFFFF.png"/>
+          <p:cNvPicPr>
+            <a:picLocks noChangeAspect="1"/>
+          </p:cNvPicPr>
+          <p:nvPr/>
+        </p:nvPicPr>
+        <p:blipFill>
+          <a:blip r:embed="rId25"/>
+          <a:stretch>
+            <a:fillRect/>
+          </a:stretch>
+        </p:blipFill>
+        <p:spPr>
+          <a:xfrm>
+            <a:off x="8350910" y="5875934"/>
+            <a:ext cx="208483" cy="208483"/>
+          </a:xfrm>
+          <a:prstGeom prst="rect">
+            <a:avLst/>
+          </a:prstGeom>
+        </p:spPr>
+      </p:pic>
+      <p:sp>
+        <p:nvSpPr>
+          <p:cNvPr id="17487" name="TextBox 17486"/>
+          <p:cNvSpPr txBox="1"/>
+          <p:nvPr/>
+        </p:nvSpPr>
+        <p:spPr>
+          <a:xfrm>
+            <a:off x="8756904" y="5760719"/>
+            <a:ext cx="3002280" cy="228600"/>
+          </a:xfrm>
+          <a:prstGeom prst="rect">
+            <a:avLst/>
+          </a:prstGeom>
+          <a:noFill/>
+        </p:spPr>
+        <p:txBody>
+          <a:bodyPr wrap="square" anchor="ctr" lIns="9144" rIns="9144" tIns="9144" bIns="9144">
+            <a:spAutoFit/>
+          </a:bodyPr>
+          <a:lstStyle/>
+          <a:p>
+            <a:pPr algn="l">
+              <a:lnSpc>
+                <a:spcPct val="100000"/>
+              </a:lnSpc>
+            </a:pPr>
+            <a:r>
+              <a:rPr sz="1100" b="1" i="0">
+                <a:solidFill>
+                  <a:srgbClr val="0070C0"/>
+                </a:solidFill>
+                <a:latin typeface="Arial"/>
+                <a:ea typeface="Arial"/>
+                <a:cs typeface="Arial"/>
+              </a:rPr>
+              <a:t>TRY OCEANSIGHT LIVE</a:t>
+            </a:r>
+          </a:p>
+        </p:txBody>
+      </p:sp>
+      <p:sp>
+        <p:nvSpPr>
+          <p:cNvPr id="17488" name="TextBox 17487"/>
+          <p:cNvSpPr txBox="1"/>
+          <p:nvPr/>
+        </p:nvSpPr>
+        <p:spPr>
+          <a:xfrm>
+            <a:off x="8756904" y="5989319"/>
+            <a:ext cx="3002280" cy="210312"/>
+          </a:xfrm>
+          <a:prstGeom prst="rect">
+            <a:avLst/>
+          </a:prstGeom>
+          <a:noFill/>
+        </p:spPr>
+        <p:txBody>
+          <a:bodyPr wrap="square" anchor="ctr" lIns="9144" rIns="9144" tIns="9144" bIns="9144">
+            <a:spAutoFit/>
+          </a:bodyPr>
+          <a:lstStyle/>
+          <a:p>
+            <a:pPr algn="l">
+              <a:lnSpc>
+                <a:spcPct val="100000"/>
+              </a:lnSpc>
+            </a:pPr>
+            <a:r>
+              <a:rPr sz="1000" b="0" i="0">
+                <a:solidFill>
+                  <a:srgbClr val="1B2330"/>
+                </a:solidFill>
+                <a:latin typeface="Arial"/>
+                <a:ea typeface="Arial"/>
+                <a:cs typeface="Arial"/>
+              </a:rPr>
+              <a:t>Access the deployed OceanSight application</a:t>
             </a:r>
           </a:p>
         </p:txBody>

</xml_diff>